<commit_message>
docs: add the video scripts and the future-ideas backlog
- `guion-tecnico-video.md`: shooting script for the presentation video —
  shots, scene-by-scene direction and the live-demo run order.
- `ideas-futuro.md`: the backlog of improvements deliberately NOT built
  during the master's. It is the evidence behind the scope-discipline
  argument: a list of ideas left untouched on purpose. It also records the
  event<->centre filter moving from "impossible by design (D10)" to shipped
  through two deliberate, written ADR revisions.
- Two script lines corrected against what the product now does: the public
  events page shows the hosting centre and the capacity, so claiming only
  "what and when" is visible was no longer true. The privacy claim is now
  the accurate one — never the exact room, never anyone's data.
- Decks refreshed.

The TFM PDF is deliberately left untracked: publishing it is the author's
call, not a side effect of tidying the repo.
</commit_message>
<xml_diff>
--- a/docs/tfm-defense-deck.pptx
+++ b/docs/tfm-defense-deck.pptx
@@ -4,6 +4,9 @@
   <p:sldMasterIdLst>
     <p:sldMasterId id="2147483648" r:id="rId1"/>
   </p:sldMasterIdLst>
+  <p:notesMasterIdLst>
+    <p:notesMasterId r:id="rId19"/>
+  </p:notesMasterIdLst>
   <p:sldIdLst>
     <p:sldId id="256" r:id="rId2"/>
     <p:sldId id="257" r:id="rId3"/>
@@ -23,9 +26,6 @@
     <p:sldId id="271" r:id="rId17"/>
     <p:sldId id="272" r:id="rId18"/>
   </p:sldIdLst>
-  <p:notesMasterIdLst>
-    <p:notesMasterId r:id="rId19"/>
-  </p:notesMasterIdLst>
   <p:sldSz cx="12192000" cy="6858000"/>
   <p:notesSz cx="6858000" cy="12192000"/>
   <p:defaultTextStyle>
@@ -120,6 +120,11 @@
       </a:defRPr>
     </a:lvl9pPr>
   </p:defaultTextStyle>
+  <p:extLst>
+    <p:ext uri="{EFAFB233-063F-42B5-8137-9DF3F51BA10A}">
+      <p15:sldGuideLst xmlns:p15="http://schemas.microsoft.com/office/powerpoint/2012/main"/>
+    </p:ext>
+  </p:extLst>
 </p:presentation>
 </file>
 
@@ -145,234 +150,10 @@
           <a:chExt cx="0" cy="0"/>
         </a:xfrm>
       </p:grpSpPr>
-      <p:sp>
-        <p:nvSpPr>
-          <p:cNvPr id="2" name="Header Placeholder 1"/>
-          <p:cNvSpPr>
-            <a:spLocks noGrp="1"/>
-          </p:cNvSpPr>
-          <p:nvPr>
-            <p:ph type="hdr" sz="quarter"/>
-          </p:nvPr>
-        </p:nvSpPr>
-        <p:spPr>
-          <a:xfrm>
-            <a:off x="0" y="0"/>
-            <a:ext cx="2971800" cy="458788"/>
-          </a:xfrm>
-          <a:prstGeom prst="rect">
-            <a:avLst/>
-          </a:prstGeom>
-        </p:spPr>
-        <p:txBody>
-          <a:bodyPr vert="horz" lIns="91440" tIns="45720" rIns="91440" bIns="45720" rtlCol="0"/>
-          <a:lstStyle>
-            <a:lvl1pPr algn="l">
-              <a:defRPr sz="1200"/>
-            </a:lvl1pPr>
-          </a:lstStyle>
-          <a:p>
-            <a:endParaRPr lang="en-US"/>
-          </a:p>
-        </p:txBody>
-      </p:sp>
-      <p:sp>
-        <p:nvSpPr>
-          <p:cNvPr id="3" name="Date Placeholder 2"/>
-          <p:cNvSpPr>
-            <a:spLocks noGrp="1"/>
-          </p:cNvSpPr>
-          <p:nvPr>
-            <p:ph type="dt" idx="1"/>
-          </p:nvPr>
-        </p:nvSpPr>
-        <p:spPr>
-          <a:xfrm>
-            <a:off x="3884613" y="0"/>
-            <a:ext cx="2971800" cy="458788"/>
-          </a:xfrm>
-          <a:prstGeom prst="rect">
-            <a:avLst/>
-          </a:prstGeom>
-        </p:spPr>
-        <p:txBody>
-          <a:bodyPr vert="horz" lIns="91440" tIns="45720" rIns="91440" bIns="45720" rtlCol="0"/>
-          <a:lstStyle>
-            <a:lvl1pPr algn="r">
-              <a:defRPr sz="1200"/>
-            </a:lvl1pPr>
-          </a:lstStyle>
-          <a:p>
-            <a:fld id="{5282F153-3F37-0F45-9E97-73ACFA13230C}" type="datetimeFigureOut">
-              <a:rPr lang="en-US"/>
-              <a:t>7/23/19</a:t>
-            </a:fld>
-            <a:endParaRPr lang="en-US"/>
-          </a:p>
-        </p:txBody>
-      </p:sp>
-      <p:sp>
-        <p:nvSpPr>
-          <p:cNvPr id="4" name="Slide Image Placeholder 3"/>
-          <p:cNvSpPr>
-            <a:spLocks noGrp="1" noRot="1" noChangeAspect="1"/>
-          </p:cNvSpPr>
-          <p:nvPr>
-            <p:ph type="sldImg" idx="2"/>
-          </p:nvPr>
-        </p:nvSpPr>
-        <p:spPr>
-          <a:xfrm>
-            <a:off x="685800" y="1143000"/>
-            <a:ext cx="5486400" cy="3086100"/>
-          </a:xfrm>
-          <a:prstGeom prst="rect">
-            <a:avLst/>
-          </a:prstGeom>
-          <a:noFill/>
-          <a:ln w="12700">
-            <a:solidFill>
-              <a:prstClr val="black"/>
-            </a:solidFill>
-          </a:ln>
-        </p:spPr>
-        <p:txBody>
-          <a:bodyPr vert="horz" lIns="91440" tIns="45720" rIns="91440" bIns="45720" rtlCol="0" anchor="ctr"/>
-          <a:lstStyle/>
-          <a:p>
-            <a:endParaRPr lang="en-US"/>
-          </a:p>
-        </p:txBody>
-      </p:sp>
-      <p:sp>
-        <p:nvSpPr>
-          <p:cNvPr id="5" name="Notes Placeholder 4"/>
-          <p:cNvSpPr>
-            <a:spLocks noGrp="1"/>
-          </p:cNvSpPr>
-          <p:nvPr>
-            <p:ph type="body" sz="quarter" idx="3"/>
-          </p:nvPr>
-        </p:nvSpPr>
-        <p:spPr>
-          <a:xfrm>
-            <a:off x="685800" y="4400550"/>
-            <a:ext cx="5486400" cy="3600450"/>
-          </a:xfrm>
-          <a:prstGeom prst="rect">
-            <a:avLst/>
-          </a:prstGeom>
-        </p:spPr>
-        <p:txBody>
-          <a:bodyPr vert="horz" lIns="91440" tIns="45720" rIns="91440" bIns="45720" rtlCol="0"/>
-          <a:lstStyle/>
-          <a:p>
-            <a:pPr lvl="0"/>
-            <a:r>
-              <a:rPr lang="en-US"/>
-              <a:t>Click to edit Master text styles</a:t>
-            </a:r>
-          </a:p>
-          <a:p>
-            <a:pPr lvl="1"/>
-            <a:r>
-              <a:rPr lang="en-US"/>
-              <a:t>Second level</a:t>
-            </a:r>
-          </a:p>
-          <a:p>
-            <a:pPr lvl="2"/>
-            <a:r>
-              <a:rPr lang="en-US"/>
-              <a:t>Third level</a:t>
-            </a:r>
-          </a:p>
-          <a:p>
-            <a:pPr lvl="3"/>
-            <a:r>
-              <a:rPr lang="en-US"/>
-              <a:t>Fourth level</a:t>
-            </a:r>
-          </a:p>
-          <a:p>
-            <a:pPr lvl="4"/>
-            <a:r>
-              <a:rPr lang="en-US"/>
-              <a:t>Fifth level</a:t>
-            </a:r>
-          </a:p>
-        </p:txBody>
-      </p:sp>
-      <p:sp>
-        <p:nvSpPr>
-          <p:cNvPr id="6" name="Footer Placeholder 5"/>
-          <p:cNvSpPr>
-            <a:spLocks noGrp="1"/>
-          </p:cNvSpPr>
-          <p:nvPr>
-            <p:ph type="ftr" sz="quarter" idx="4"/>
-          </p:nvPr>
-        </p:nvSpPr>
-        <p:spPr>
-          <a:xfrm>
-            <a:off x="0" y="8685213"/>
-            <a:ext cx="2971800" cy="458787"/>
-          </a:xfrm>
-          <a:prstGeom prst="rect">
-            <a:avLst/>
-          </a:prstGeom>
-        </p:spPr>
-        <p:txBody>
-          <a:bodyPr vert="horz" lIns="91440" tIns="45720" rIns="91440" bIns="45720" rtlCol="0" anchor="b"/>
-          <a:lstStyle>
-            <a:lvl1pPr algn="l">
-              <a:defRPr sz="1200"/>
-            </a:lvl1pPr>
-          </a:lstStyle>
-          <a:p>
-            <a:endParaRPr lang="en-US"/>
-          </a:p>
-        </p:txBody>
-      </p:sp>
-      <p:sp>
-        <p:nvSpPr>
-          <p:cNvPr id="7" name="Slide Number Placeholder 6"/>
-          <p:cNvSpPr>
-            <a:spLocks noGrp="1"/>
-          </p:cNvSpPr>
-          <p:nvPr>
-            <p:ph type="sldNum" sz="quarter" idx="5"/>
-          </p:nvPr>
-        </p:nvSpPr>
-        <p:spPr>
-          <a:xfrm>
-            <a:off x="3884613" y="8685213"/>
-            <a:ext cx="2971800" cy="458787"/>
-          </a:xfrm>
-          <a:prstGeom prst="rect">
-            <a:avLst/>
-          </a:prstGeom>
-        </p:spPr>
-        <p:txBody>
-          <a:bodyPr vert="horz" lIns="91440" tIns="45720" rIns="91440" bIns="45720" rtlCol="0" anchor="b"/>
-          <a:lstStyle>
-            <a:lvl1pPr algn="r">
-              <a:defRPr sz="1200"/>
-            </a:lvl1pPr>
-          </a:lstStyle>
-          <a:p>
-            <a:fld id="{CE5E9CC1-C706-0F49-92D6-E571CC5EEA8F}" type="slidenum">
-              <a:rPr lang="en-US"/>
-              <a:t>‹#›</a:t>
-            </a:fld>
-            <a:endParaRPr lang="en-US"/>
-          </a:p>
-        </p:txBody>
-      </p:sp>
     </p:spTree>
     <p:extLst>
       <p:ext uri="{BB962C8B-B14F-4D97-AF65-F5344CB8AC3E}">
-        <p14:creationId xmlns:p14="http://schemas.microsoft.com/office/powerpoint/2010/main" val="1024086991"/>
+        <p14:creationId xmlns:p14="http://schemas.microsoft.com/office/powerpoint/2010/main" val="1510827444"/>
       </p:ext>
     </p:extLst>
   </p:cSld>
@@ -520,7 +301,6 @@
               <a:rPr lang="en-US" dirty="0"/>
               <a:t>Este proyecto no es un sistema clínico y no gestiona historiales de salud. Aborda un problema de coordinación más acotado pero real: convertir el tiempo disponible en centros de cuidado — un hospital, pero también una residencia, un centro de día, un hospital de día, un centro ocupacional o una unidad de cuidados paliativos — y las ofertas culturales en eventos públicos seguros y trazables.</a:t>
             </a:r>
-            <a:endParaRPr lang="en-US" dirty="0"/>
           </a:p>
         </p:txBody>
       </p:sp>
@@ -608,7 +388,6 @@
               <a:rPr lang="en-US" dirty="0"/>
               <a:t>El valor de la IA es aceleración con restricciones, no corrección automática. El proyecto trata la salida generada como una entrada a un proceso de ingeniería revisable, no como evidencia por sí misma.</a:t>
             </a:r>
-            <a:endParaRPr lang="en-US" dirty="0"/>
           </a:p>
         </p:txBody>
       </p:sp>
@@ -696,7 +475,6 @@
               <a:rPr lang="en-US" dirty="0"/>
               <a:t>Este es un diferenciador central del proyecto. El proceso de revisión no oculta defectos. Los convierte en cambios de diseño explícitos o en compuertas de release. Los hallazgos de dominio y hardening que la revisión dejó abiertos ahora están cerrados y en revisión.</a:t>
             </a:r>
-            <a:endParaRPr lang="en-US" dirty="0"/>
           </a:p>
         </p:txBody>
       </p:sp>
@@ -784,7 +562,6 @@
               <a:rPr lang="en-US" dirty="0"/>
               <a:t>El TDD estricto selectivo se enfoca en las reglas más valiosas: transiciones de estado e invariantes de negocio. Los dobles en memoria prueban orquestación pero no un row lock o un rollback — por eso la evidencia de concurrencia viene de PostgreSQL real en CI. Localmente estos tests de carrera se saltan por defecto; CI con un Postgres local es el registro autoritativo. Refrescá los recuentos exactos antes de la defensa.</a:t>
             </a:r>
-            <a:endParaRPr lang="en-US" dirty="0"/>
           </a:p>
         </p:txBody>
       </p:sp>
@@ -872,7 +649,6 @@
               <a:rPr lang="en-US" dirty="0"/>
               <a:t>La seguridad es arquitectura e implementación. Los controles que una revisión anterior del threat model llamó pendientes — el DTO público en runtime, CSRF en cada ruta, el adaptador de sesión, el rate limiting atómico — están integrados y cada uno cita un test que se ejecutó. Los headers, el CSP con nonce y el escaneo de dependencias ahora están implementados (PR #32, en revisión). Lo que sigue sin estar es el logging de seguridad. Es un MVP defendible, no un servicio listo para internet, y el threat model lo dice control por control.</a:t>
             </a:r>
-            <a:endParaRPr lang="en-US" dirty="0"/>
           </a:p>
         </p:txBody>
       </p:sp>
@@ -960,7 +736,6 @@
               <a:rPr lang="en-US" dirty="0"/>
               <a:t>Esta cadena no es aspiracional: e2e/demo-chain.spec.ts automatiza exactamente estos seis pasos y pasó en CI contra PostgreSQL real y datos semilla, y un test compañero afirma que la respuesta pública contiene solo los campos permitidos. Decidí cómo correr la demo el día: o grabás una de antemano identificada como grabada y con la misma revisión desplegada, o la hacés en vivo siendo explícito de que CI es el registro reproducible.</a:t>
             </a:r>
-            <a:endParaRPr lang="en-US" dirty="0"/>
           </a:p>
         </p:txBody>
       </p:sp>
@@ -1048,7 +823,6 @@
               <a:rPr lang="en-US" dirty="0"/>
               <a:t>Esta diapositiva es deliberadamente explícita, y la columna del medio es la honesta. Un TFM defendible no convierte una decisión de diseño en una garantía de producción — pero tampoco debe infravalorar la evidencia que existe. El núcleo está desplegado y sus propiedades de concurrencia, autorización y minimización de datos están probadas por tests que se ejecutaron. El siguiente hito es logging y observabilidad, no alcance de features. Si el repo sigue privado, decilo abiertamente.</a:t>
             </a:r>
-            <a:endParaRPr lang="en-US" dirty="0"/>
           </a:p>
         </p:txBody>
       </p:sp>
@@ -1136,7 +910,6 @@
               <a:rPr lang="en-US" dirty="0"/>
               <a:t>La arquitectura deja puntos de extensión, pero extender no es licencia para saltar la seguridad. Pagos, integraciones externas y features más ricas de cara al paciente requieren cada una su propio modelado de amenazas antes de implementarse.</a:t>
             </a:r>
-            <a:endParaRPr lang="en-US" dirty="0"/>
           </a:p>
         </p:txBody>
       </p:sp>
@@ -1224,7 +997,6 @@
               <a:rPr lang="en-US" dirty="0"/>
               <a:t>El aprendizaje principal no es una elección de framework. Es la disciplina de tratar las reglas de negocio, las restricciones de seguridad y la evidencia de verificación como parte del producto. Gracias — las preguntas son bienvenidas.</a:t>
             </a:r>
-            <a:endParaRPr lang="en-US" dirty="0"/>
           </a:p>
         </p:txBody>
       </p:sp>
@@ -1312,7 +1084,6 @@
               <a:rPr lang="en-US" dirty="0"/>
               <a:t>El diferenciador no es inventar cultura en entornos de cuidado. Es modelar la capa de coordinación que conecta un hueco disponible en un centro con propuestas de actividad que compiten, preservando gobernanza y confidencialidad.</a:t>
             </a:r>
-            <a:endParaRPr lang="en-US" dirty="0"/>
           </a:p>
         </p:txBody>
       </p:sp>
@@ -1400,7 +1171,6 @@
               <a:rPr lang="en-US" dirty="0"/>
               <a:t>La regla central no es deliberadamente 'primero que llega'. Un Slot puede tener varias propuestas y el centro propietario elige la que mejor encaja en su contexto — la misma regla para un hospital, una residencia o una unidad de paliativos.</a:t>
             </a:r>
-            <a:endParaRPr lang="en-US" dirty="0"/>
           </a:p>
         </p:txBody>
       </p:sp>
@@ -1488,7 +1258,6 @@
               <a:rPr lang="en-US" dirty="0"/>
               <a:t>El alcance es intencionadamente secuencial. Un núcleo completo y demostrable es más defendible que varios módulos a medias. Los pagos reales quedan explícitamente fuera; el bloque simulado modela solo un límite de adaptador. La generalización a seis tipos de centro está mergeada y desplegada; la revisión nativa de euskera y el reseed de producción siguen pendientes.</a:t>
             </a:r>
-            <a:endParaRPr lang="en-US" dirty="0"/>
           </a:p>
         </p:txBody>
       </p:sp>
@@ -1576,7 +1345,6 @@
               <a:rPr lang="en-US" dirty="0"/>
               <a:t>El proyecto elige simplicidad intencionada. Microservicios o Kubernetes añadirían complejidad de despliegue y observabilidad sin mejorar este flujo. Las sesiones se eligen porque la gobernanza exige revocación, no porque JWT sea inherentemente incorrecto.</a:t>
             </a:r>
-            <a:endParaRPr lang="en-US" dirty="0"/>
           </a:p>
         </p:txBody>
       </p:sp>
@@ -1664,7 +1432,6 @@
               <a:rPr lang="en-US" dirty="0"/>
               <a:t>La prueba arquitectónica es simple: las reglas de negocio deben seguir siendo testeables si reemplazamos Prisma o el framework de entrega. La afirmación graduable más fuerte del proyecto vive aquí: como rol y tipo de centro son ejes separados, ampliar de un tipo de centro a seis tocó el eje de datos y el copy, pero no la superficie de autorización — el predicado de seguridad siguió siendo un único literal, type: 'CENTRE', nunca una lista de seis valores.</a:t>
             </a:r>
-            <a:endParaRPr lang="en-US" dirty="0"/>
           </a:p>
         </p:txBody>
       </p:sp>
@@ -1752,7 +1519,6 @@
               <a:rPr lang="en-US" dirty="0"/>
               <a:t>Los estados explícitos hacen visibles los caminos inválidos. Por ejemplo, una Propuesta terminal no puede volver a aceptarse, y un Perfil no activo no puede ejecutar sus acciones de rol. El estado 'completed' del Evento es una costura deliberada para el Bloque 2.</a:t>
             </a:r>
-            <a:endParaRPr lang="en-US" dirty="0"/>
           </a:p>
         </p:txBody>
       </p:sp>
@@ -1840,7 +1606,6 @@
               <a:rPr lang="en-US" dirty="0"/>
               <a:t>La idea clave vino de una revisión adversarial: bloquear después de una decisión es demasiado tarde. Una propuesta concurrente podría sobrevivir en un Slot filled. El contrato se implementa como SELECT … FOR UPDATE sobre la fila del Slot antes de cualquier lectura que informe la decisión, y está probado — nueve escenarios de carrera forzados con barreras explícitas en ambos órdenes, ejecutados contra PostgreSQL real en CI.</a:t>
             </a:r>
-            <a:endParaRPr lang="en-US" dirty="0"/>
           </a:p>
         </p:txBody>
       </p:sp>
@@ -1928,7 +1693,6 @@
               <a:rPr lang="en-US" dirty="0"/>
               <a:t>La especificación no es documentación escrita al final. Es el contrato usado para decidir qué debe implementarse y, tan importante como eso, qué no debe afirmarse todavía.</a:t>
             </a:r>
-            <a:endParaRPr lang="en-US" dirty="0"/>
           </a:p>
         </p:txBody>
       </p:sp>
@@ -2001,6 +1765,11 @@
 <file path=ppt/slideMasters/slideMaster1.xml><?xml version="1.0" encoding="utf-8"?>
 <p:sldMaster xmlns:a="http://schemas.openxmlformats.org/drawingml/2006/main" xmlns:r="http://schemas.openxmlformats.org/officeDocument/2006/relationships" xmlns:p="http://schemas.openxmlformats.org/presentationml/2006/main">
   <p:cSld>
+    <p:bg>
+      <p:bgRef idx="1001">
+        <a:schemeClr val="bg1"/>
+      </p:bgRef>
+    </p:bg>
     <p:spTree>
       <p:nvGrpSpPr>
         <p:cNvPr id="1" name=""/>
@@ -2283,6 +2052,7 @@
         <a:solidFill>
           <a:srgbClr val="1E2B2D"/>
         </a:solidFill>
+        <a:effectLst/>
       </p:bgPr>
     </p:bg>
     <p:spTree>
@@ -2318,6 +2088,13 @@
           </a:solidFill>
           <a:ln/>
         </p:spPr>
+        <p:txBody>
+          <a:bodyPr/>
+          <a:lstStyle/>
+          <a:p>
+            <a:endParaRPr lang="es-ES"/>
+          </a:p>
+        </p:txBody>
       </p:sp>
       <p:sp>
         <p:nvSpPr>
@@ -2338,6 +2115,13 @@
           </a:solidFill>
           <a:ln/>
         </p:spPr>
+        <p:txBody>
+          <a:bodyPr/>
+          <a:lstStyle/>
+          <a:p>
+            <a:endParaRPr lang="es-ES"/>
+          </a:p>
+        </p:txBody>
       </p:sp>
       <p:sp>
         <p:nvSpPr>
@@ -2358,6 +2142,13 @@
           </a:solidFill>
           <a:ln/>
         </p:spPr>
+        <p:txBody>
+          <a:bodyPr/>
+          <a:lstStyle/>
+          <a:p>
+            <a:endParaRPr lang="es-ES"/>
+          </a:p>
+        </p:txBody>
       </p:sp>
       <p:sp>
         <p:nvSpPr>
@@ -2380,11 +2171,11 @@
           <a:bodyPr wrap="square" lIns="0" tIns="0" rIns="0" bIns="0" rtlCol="0" anchor="ctr"/>
           <a:lstStyle/>
           <a:p>
-            <a:pPr indent="0" marL="0">
-              <a:buNone/>
-            </a:pPr>
-            <a:r>
-              <a:rPr lang="en-US" sz="1300" b="1" spc="300" kern="0" dirty="0">
+            <a:pPr marL="0" indent="0">
+              <a:buNone/>
+            </a:pPr>
+            <a:r>
+              <a:rPr lang="en-US" sz="1300" b="1" kern="0" spc="300" dirty="0">
                 <a:solidFill>
                   <a:srgbClr val="84B59F"/>
                 </a:solidFill>
@@ -2392,7 +2183,7 @@
                 <a:ea typeface="Calibri" pitchFamily="34" charset="-122"/>
                 <a:cs typeface="Calibri" pitchFamily="34" charset="-120"/>
               </a:rPr>
-              <a:t>VIVETUTIEMPO — TRABAJO FIN DE MÁSTER</a:t>
+              <a:t>TODOELTIEMPOCUENTA — TRABAJO FIN DE MÁSTER</a:t>
             </a:r>
             <a:endParaRPr lang="en-US" sz="1300" dirty="0"/>
           </a:p>
@@ -2419,7 +2210,7 @@
           <a:bodyPr wrap="square" lIns="0" tIns="0" rIns="0" bIns="0" rtlCol="0" anchor="ctr"/>
           <a:lstStyle/>
           <a:p>
-            <a:pPr indent="0" marL="0">
+            <a:pPr marL="0" indent="0">
               <a:buNone/>
             </a:pPr>
             <a:r>
@@ -2458,7 +2249,7 @@
           <a:bodyPr wrap="square" lIns="0" tIns="0" rIns="0" bIns="0" rtlCol="0" anchor="ctr"/>
           <a:lstStyle/>
           <a:p>
-            <a:pPr indent="0" marL="0">
+            <a:pPr marL="0" indent="0">
               <a:lnSpc>
                 <a:spcPct val="110000"/>
               </a:lnSpc>
@@ -2500,7 +2291,7 @@
           <a:bodyPr wrap="square" lIns="0" tIns="0" rIns="0" bIns="0" rtlCol="0" anchor="ctr"/>
           <a:lstStyle/>
           <a:p>
-            <a:pPr indent="0" marL="0">
+            <a:pPr marL="0" indent="0">
               <a:buNone/>
             </a:pPr>
             <a:r>
@@ -2539,7 +2330,7 @@
           <a:bodyPr wrap="square" lIns="0" tIns="0" rIns="0" bIns="0" rtlCol="0" anchor="ctr"/>
           <a:lstStyle/>
           <a:p>
-            <a:pPr indent="0" marL="0">
+            <a:pPr marL="0" indent="0">
               <a:buNone/>
             </a:pPr>
             <a:r>
@@ -2551,7 +2342,73 @@
                 <a:ea typeface="Calibri" pitchFamily="34" charset="-122"/>
                 <a:cs typeface="Calibri" pitchFamily="34" charset="-120"/>
               </a:rPr>
-              <a:t>[AUTOR] · Máster [programa] · Curso [año] · Tutor/a [nombre]</a:t>
+              <a:t>Koldobika Legorburu Segurola · </a:t>
+            </a:r>
+            <a:r>
+              <a:rPr lang="en-US" sz="1300" i="1" dirty="0" err="1">
+                <a:solidFill>
+                  <a:srgbClr val="9FB4AF"/>
+                </a:solidFill>
+                <a:latin typeface="Calibri" pitchFamily="34" charset="0"/>
+                <a:ea typeface="Calibri" pitchFamily="34" charset="-122"/>
+                <a:cs typeface="Calibri" pitchFamily="34" charset="-120"/>
+              </a:rPr>
+              <a:t>Máster</a:t>
+            </a:r>
+            <a:r>
+              <a:rPr lang="en-US" sz="1300" i="1" dirty="0">
+                <a:solidFill>
+                  <a:srgbClr val="9FB4AF"/>
+                </a:solidFill>
+                <a:latin typeface="Calibri" pitchFamily="34" charset="0"/>
+                <a:ea typeface="Calibri" pitchFamily="34" charset="-122"/>
+                <a:cs typeface="Calibri" pitchFamily="34" charset="-120"/>
+              </a:rPr>
+              <a:t> </a:t>
+            </a:r>
+            <a:r>
+              <a:rPr lang="en-US" sz="1300" i="1" dirty="0" err="1">
+                <a:solidFill>
+                  <a:srgbClr val="9FB4AF"/>
+                </a:solidFill>
+                <a:latin typeface="Calibri" pitchFamily="34" charset="0"/>
+                <a:ea typeface="Calibri" pitchFamily="34" charset="-122"/>
+                <a:cs typeface="Calibri" pitchFamily="34" charset="-120"/>
+              </a:rPr>
+              <a:t>en</a:t>
+            </a:r>
+            <a:r>
+              <a:rPr lang="en-US" sz="1300" i="1" dirty="0">
+                <a:solidFill>
+                  <a:srgbClr val="9FB4AF"/>
+                </a:solidFill>
+                <a:latin typeface="Calibri" pitchFamily="34" charset="0"/>
+                <a:ea typeface="Calibri" pitchFamily="34" charset="-122"/>
+                <a:cs typeface="Calibri" pitchFamily="34" charset="-120"/>
+              </a:rPr>
+              <a:t> Desarrollo con IA – E. II · </a:t>
+            </a:r>
+            <a:r>
+              <a:rPr lang="en-US" sz="1300" i="1" dirty="0" err="1">
+                <a:solidFill>
+                  <a:srgbClr val="9FB4AF"/>
+                </a:solidFill>
+                <a:latin typeface="Calibri" pitchFamily="34" charset="0"/>
+                <a:ea typeface="Calibri" pitchFamily="34" charset="-122"/>
+                <a:cs typeface="Calibri" pitchFamily="34" charset="-120"/>
+              </a:rPr>
+              <a:t>Curso</a:t>
+            </a:r>
+            <a:r>
+              <a:rPr lang="en-US" sz="1300" i="1" dirty="0">
+                <a:solidFill>
+                  <a:srgbClr val="9FB4AF"/>
+                </a:solidFill>
+                <a:latin typeface="Calibri" pitchFamily="34" charset="0"/>
+                <a:ea typeface="Calibri" pitchFamily="34" charset="-122"/>
+                <a:cs typeface="Calibri" pitchFamily="34" charset="-120"/>
+              </a:rPr>
+              <a:t> 2026 · Tutor/a Brais Moure</a:t>
             </a:r>
             <a:endParaRPr lang="en-US" sz="1300" dirty="0"/>
           </a:p>
@@ -2573,6 +2430,7 @@
         <a:solidFill>
           <a:srgbClr val="F5F5F2"/>
         </a:solidFill>
+        <a:effectLst/>
       </p:bgPr>
     </p:bg>
     <p:spTree>
@@ -2610,11 +2468,11 @@
           <a:bodyPr wrap="square" lIns="0" tIns="0" rIns="0" bIns="0" rtlCol="0" anchor="ctr"/>
           <a:lstStyle/>
           <a:p>
-            <a:pPr indent="0" marL="0">
-              <a:buNone/>
-            </a:pPr>
-            <a:r>
-              <a:rPr lang="en-US" sz="1200" b="1" spc="300" kern="0" dirty="0">
+            <a:pPr marL="0" indent="0">
+              <a:buNone/>
+            </a:pPr>
+            <a:r>
+              <a:rPr lang="en-US" sz="1200" b="1" kern="0" spc="300" dirty="0">
                 <a:solidFill>
                   <a:srgbClr val="69A297"/>
                 </a:solidFill>
@@ -2649,7 +2507,7 @@
           <a:bodyPr wrap="square" lIns="0" tIns="0" rIns="0" bIns="0" rtlCol="0" anchor="ctr"/>
           <a:lstStyle/>
           <a:p>
-            <a:pPr indent="0" marL="0">
+            <a:pPr marL="0" indent="0">
               <a:lnSpc>
                 <a:spcPct val="98000"/>
               </a:lnSpc>
@@ -2691,13 +2549,20 @@
           </a:solidFill>
           <a:ln/>
           <a:effectLst>
-            <a:outerShdw sx="100000" sy="100000" kx="0" ky="0" algn="bl" rotWithShape="0" blurRad="101600" dist="38100" dir="5400000">
+            <a:outerShdw blurRad="101600" dist="38100" dir="5400000" algn="bl" rotWithShape="0">
               <a:srgbClr val="9AA8A5">
                 <a:alpha val="28000"/>
               </a:srgbClr>
             </a:outerShdw>
           </a:effectLst>
         </p:spPr>
+        <p:txBody>
+          <a:bodyPr/>
+          <a:lstStyle/>
+          <a:p>
+            <a:endParaRPr lang="es-ES"/>
+          </a:p>
+        </p:txBody>
       </p:sp>
       <p:sp>
         <p:nvSpPr>
@@ -2720,7 +2585,7 @@
           <a:bodyPr wrap="square" lIns="0" tIns="0" rIns="0" bIns="0" rtlCol="0" anchor="ctr"/>
           <a:lstStyle/>
           <a:p>
-            <a:pPr algn="ctr" indent="0" marL="0">
+            <a:pPr marL="0" indent="0" algn="ctr">
               <a:buNone/>
             </a:pPr>
             <a:r>
@@ -2759,7 +2624,7 @@
           <a:bodyPr wrap="square" lIns="0" tIns="0" rIns="0" bIns="0" rtlCol="0" anchor="ctr"/>
           <a:lstStyle/>
           <a:p>
-            <a:pPr algn="ctr" indent="0" marL="0">
+            <a:pPr marL="0" indent="0" algn="ctr">
               <a:buNone/>
             </a:pPr>
             <a:r>
@@ -2798,13 +2663,20 @@
           </a:solidFill>
           <a:ln/>
           <a:effectLst>
-            <a:outerShdw sx="100000" sy="100000" kx="0" ky="0" algn="bl" rotWithShape="0" blurRad="101600" dist="38100" dir="5400000">
+            <a:outerShdw blurRad="101600" dist="38100" dir="5400000" algn="bl" rotWithShape="0">
               <a:srgbClr val="9AA8A5">
                 <a:alpha val="28000"/>
               </a:srgbClr>
             </a:outerShdw>
           </a:effectLst>
         </p:spPr>
+        <p:txBody>
+          <a:bodyPr/>
+          <a:lstStyle/>
+          <a:p>
+            <a:endParaRPr lang="es-ES"/>
+          </a:p>
+        </p:txBody>
       </p:sp>
       <p:sp>
         <p:nvSpPr>
@@ -2827,7 +2699,7 @@
           <a:bodyPr wrap="square" lIns="0" tIns="0" rIns="0" bIns="0" rtlCol="0" anchor="ctr"/>
           <a:lstStyle/>
           <a:p>
-            <a:pPr algn="ctr" indent="0" marL="0">
+            <a:pPr marL="0" indent="0" algn="ctr">
               <a:buNone/>
             </a:pPr>
             <a:r>
@@ -2866,7 +2738,7 @@
           <a:bodyPr wrap="square" lIns="0" tIns="0" rIns="0" bIns="0" rtlCol="0" anchor="ctr"/>
           <a:lstStyle/>
           <a:p>
-            <a:pPr algn="ctr" indent="0" marL="0">
+            <a:pPr marL="0" indent="0" algn="ctr">
               <a:buNone/>
             </a:pPr>
             <a:r>
@@ -2905,13 +2777,20 @@
           </a:solidFill>
           <a:ln/>
           <a:effectLst>
-            <a:outerShdw sx="100000" sy="100000" kx="0" ky="0" algn="bl" rotWithShape="0" blurRad="101600" dist="38100" dir="5400000">
+            <a:outerShdw blurRad="101600" dist="38100" dir="5400000" algn="bl" rotWithShape="0">
               <a:srgbClr val="9AA8A5">
                 <a:alpha val="28000"/>
               </a:srgbClr>
             </a:outerShdw>
           </a:effectLst>
         </p:spPr>
+        <p:txBody>
+          <a:bodyPr/>
+          <a:lstStyle/>
+          <a:p>
+            <a:endParaRPr lang="es-ES"/>
+          </a:p>
+        </p:txBody>
       </p:sp>
       <p:sp>
         <p:nvSpPr>
@@ -2934,7 +2813,7 @@
           <a:bodyPr wrap="square" lIns="0" tIns="0" rIns="0" bIns="0" rtlCol="0" anchor="ctr"/>
           <a:lstStyle/>
           <a:p>
-            <a:pPr algn="ctr" indent="0" marL="0">
+            <a:pPr marL="0" indent="0" algn="ctr">
               <a:buNone/>
             </a:pPr>
             <a:r>
@@ -2973,7 +2852,7 @@
           <a:bodyPr wrap="square" lIns="0" tIns="0" rIns="0" bIns="0" rtlCol="0" anchor="ctr"/>
           <a:lstStyle/>
           <a:p>
-            <a:pPr algn="ctr" indent="0" marL="0">
+            <a:pPr marL="0" indent="0" algn="ctr">
               <a:buNone/>
             </a:pPr>
             <a:r>
@@ -3012,13 +2891,20 @@
           </a:solidFill>
           <a:ln/>
           <a:effectLst>
-            <a:outerShdw sx="100000" sy="100000" kx="0" ky="0" algn="bl" rotWithShape="0" blurRad="101600" dist="38100" dir="5400000">
+            <a:outerShdw blurRad="101600" dist="38100" dir="5400000" algn="bl" rotWithShape="0">
               <a:srgbClr val="9AA8A5">
                 <a:alpha val="28000"/>
               </a:srgbClr>
             </a:outerShdw>
           </a:effectLst>
         </p:spPr>
+        <p:txBody>
+          <a:bodyPr/>
+          <a:lstStyle/>
+          <a:p>
+            <a:endParaRPr lang="es-ES"/>
+          </a:p>
+        </p:txBody>
       </p:sp>
       <p:sp>
         <p:nvSpPr>
@@ -3041,7 +2927,7 @@
           <a:bodyPr wrap="square" lIns="0" tIns="0" rIns="0" bIns="0" rtlCol="0" anchor="ctr"/>
           <a:lstStyle/>
           <a:p>
-            <a:pPr algn="ctr" indent="0" marL="0">
+            <a:pPr marL="0" indent="0" algn="ctr">
               <a:buNone/>
             </a:pPr>
             <a:r>
@@ -3186,7 +3072,7 @@
           <a:bodyPr wrap="square" rtlCol="0" anchor="ctr"/>
           <a:lstStyle/>
           <a:p>
-            <a:pPr algn="r" indent="0" marL="0">
+            <a:pPr marL="0" indent="0" algn="r">
               <a:buNone/>
             </a:pPr>
             <a:r>
@@ -3220,6 +3106,7 @@
         <a:solidFill>
           <a:srgbClr val="1E2B2D"/>
         </a:solidFill>
+        <a:effectLst/>
       </p:bgPr>
     </p:bg>
     <p:spTree>
@@ -3257,11 +3144,11 @@
           <a:bodyPr wrap="square" lIns="0" tIns="0" rIns="0" bIns="0" rtlCol="0" anchor="ctr"/>
           <a:lstStyle/>
           <a:p>
-            <a:pPr indent="0" marL="0">
-              <a:buNone/>
-            </a:pPr>
-            <a:r>
-              <a:rPr lang="en-US" sz="1200" b="1" spc="300" kern="0" dirty="0">
+            <a:pPr marL="0" indent="0">
+              <a:buNone/>
+            </a:pPr>
+            <a:r>
+              <a:rPr lang="en-US" sz="1200" b="1" kern="0" spc="300" dirty="0">
                 <a:solidFill>
                   <a:srgbClr val="84B59F"/>
                 </a:solidFill>
@@ -3296,7 +3183,7 @@
           <a:bodyPr wrap="square" lIns="0" tIns="0" rIns="0" bIns="0" rtlCol="0" anchor="ctr"/>
           <a:lstStyle/>
           <a:p>
-            <a:pPr indent="0" marL="0">
+            <a:pPr marL="0" indent="0">
               <a:lnSpc>
                 <a:spcPct val="98000"/>
               </a:lnSpc>
@@ -3338,6 +3225,13 @@
           </a:solidFill>
           <a:ln/>
         </p:spPr>
+        <p:txBody>
+          <a:bodyPr/>
+          <a:lstStyle/>
+          <a:p>
+            <a:endParaRPr lang="es-ES"/>
+          </a:p>
+        </p:txBody>
       </p:sp>
       <p:sp>
         <p:nvSpPr>
@@ -3360,7 +3254,7 @@
           <a:bodyPr wrap="square" lIns="0" tIns="0" rIns="0" bIns="0" rtlCol="0" anchor="t"/>
           <a:lstStyle/>
           <a:p>
-            <a:pPr indent="0" marL="0">
+            <a:pPr marL="0" indent="0">
               <a:buNone/>
             </a:pPr>
             <a:r>
@@ -3399,7 +3293,7 @@
           <a:bodyPr wrap="square" lIns="0" tIns="0" rIns="0" bIns="0" rtlCol="0" anchor="t"/>
           <a:lstStyle/>
           <a:p>
-            <a:pPr indent="0" marL="0">
+            <a:pPr marL="0" indent="0">
               <a:lnSpc>
                 <a:spcPct val="105000"/>
               </a:lnSpc>
@@ -3441,7 +3335,7 @@
           <a:bodyPr wrap="square" lIns="0" tIns="0" rIns="0" bIns="0" rtlCol="0" anchor="t"/>
           <a:lstStyle/>
           <a:p>
-            <a:pPr indent="0" marL="0">
+            <a:pPr marL="0" indent="0">
               <a:lnSpc>
                 <a:spcPct val="105000"/>
               </a:lnSpc>
@@ -3483,6 +3377,13 @@
           </a:solidFill>
           <a:ln/>
         </p:spPr>
+        <p:txBody>
+          <a:bodyPr/>
+          <a:lstStyle/>
+          <a:p>
+            <a:endParaRPr lang="es-ES"/>
+          </a:p>
+        </p:txBody>
       </p:sp>
       <p:sp>
         <p:nvSpPr>
@@ -3505,7 +3406,7 @@
           <a:bodyPr wrap="square" lIns="0" tIns="0" rIns="0" bIns="0" rtlCol="0" anchor="t"/>
           <a:lstStyle/>
           <a:p>
-            <a:pPr indent="0" marL="0">
+            <a:pPr marL="0" indent="0">
               <a:buNone/>
             </a:pPr>
             <a:r>
@@ -3544,7 +3445,7 @@
           <a:bodyPr wrap="square" lIns="0" tIns="0" rIns="0" bIns="0" rtlCol="0" anchor="t"/>
           <a:lstStyle/>
           <a:p>
-            <a:pPr indent="0" marL="0">
+            <a:pPr marL="0" indent="0">
               <a:lnSpc>
                 <a:spcPct val="105000"/>
               </a:lnSpc>
@@ -3586,7 +3487,7 @@
           <a:bodyPr wrap="square" lIns="0" tIns="0" rIns="0" bIns="0" rtlCol="0" anchor="t"/>
           <a:lstStyle/>
           <a:p>
-            <a:pPr indent="0" marL="0">
+            <a:pPr marL="0" indent="0">
               <a:lnSpc>
                 <a:spcPct val="105000"/>
               </a:lnSpc>
@@ -3628,6 +3529,13 @@
           </a:solidFill>
           <a:ln/>
         </p:spPr>
+        <p:txBody>
+          <a:bodyPr/>
+          <a:lstStyle/>
+          <a:p>
+            <a:endParaRPr lang="es-ES"/>
+          </a:p>
+        </p:txBody>
       </p:sp>
       <p:sp>
         <p:nvSpPr>
@@ -3650,7 +3558,7 @@
           <a:bodyPr wrap="square" lIns="0" tIns="0" rIns="0" bIns="0" rtlCol="0" anchor="t"/>
           <a:lstStyle/>
           <a:p>
-            <a:pPr indent="0" marL="0">
+            <a:pPr marL="0" indent="0">
               <a:buNone/>
             </a:pPr>
             <a:r>
@@ -3689,7 +3597,7 @@
           <a:bodyPr wrap="square" lIns="0" tIns="0" rIns="0" bIns="0" rtlCol="0" anchor="t"/>
           <a:lstStyle/>
           <a:p>
-            <a:pPr indent="0" marL="0">
+            <a:pPr marL="0" indent="0">
               <a:lnSpc>
                 <a:spcPct val="105000"/>
               </a:lnSpc>
@@ -3731,7 +3639,7 @@
           <a:bodyPr wrap="square" lIns="0" tIns="0" rIns="0" bIns="0" rtlCol="0" anchor="t"/>
           <a:lstStyle/>
           <a:p>
-            <a:pPr indent="0" marL="0">
+            <a:pPr marL="0" indent="0">
               <a:lnSpc>
                 <a:spcPct val="105000"/>
               </a:lnSpc>
@@ -3773,7 +3681,7 @@
           <a:bodyPr wrap="square" lIns="0" tIns="0" rIns="0" bIns="0" rtlCol="0" anchor="ctr"/>
           <a:lstStyle/>
           <a:p>
-            <a:pPr indent="0" marL="0">
+            <a:pPr marL="0" indent="0">
               <a:buNone/>
             </a:pPr>
             <a:r>
@@ -3812,7 +3720,7 @@
           <a:bodyPr wrap="square" rtlCol="0" anchor="ctr"/>
           <a:lstStyle/>
           <a:p>
-            <a:pPr algn="r" indent="0" marL="0">
+            <a:pPr marL="0" indent="0" algn="r">
               <a:buNone/>
             </a:pPr>
             <a:r>
@@ -3846,6 +3754,7 @@
         <a:solidFill>
           <a:srgbClr val="F5F5F2"/>
         </a:solidFill>
+        <a:effectLst/>
       </p:bgPr>
     </p:bg>
     <p:spTree>
@@ -3883,11 +3792,11 @@
           <a:bodyPr wrap="square" lIns="0" tIns="0" rIns="0" bIns="0" rtlCol="0" anchor="ctr"/>
           <a:lstStyle/>
           <a:p>
-            <a:pPr indent="0" marL="0">
-              <a:buNone/>
-            </a:pPr>
-            <a:r>
-              <a:rPr lang="en-US" sz="1200" b="1" spc="300" kern="0" dirty="0">
+            <a:pPr marL="0" indent="0">
+              <a:buNone/>
+            </a:pPr>
+            <a:r>
+              <a:rPr lang="en-US" sz="1200" b="1" kern="0" spc="300" dirty="0">
                 <a:solidFill>
                   <a:srgbClr val="69A297"/>
                 </a:solidFill>
@@ -3922,7 +3831,7 @@
           <a:bodyPr wrap="square" lIns="0" tIns="0" rIns="0" bIns="0" rtlCol="0" anchor="ctr"/>
           <a:lstStyle/>
           <a:p>
-            <a:pPr indent="0" marL="0">
+            <a:pPr marL="0" indent="0">
               <a:lnSpc>
                 <a:spcPct val="98000"/>
               </a:lnSpc>
@@ -3964,6 +3873,13 @@
           </a:solidFill>
           <a:ln/>
         </p:spPr>
+        <p:txBody>
+          <a:bodyPr/>
+          <a:lstStyle/>
+          <a:p>
+            <a:endParaRPr lang="es-ES"/>
+          </a:p>
+        </p:txBody>
       </p:sp>
       <p:sp>
         <p:nvSpPr>
@@ -3986,7 +3902,7 @@
           <a:bodyPr wrap="square" lIns="0" tIns="0" rIns="0" bIns="0" rtlCol="0" anchor="ctr"/>
           <a:lstStyle/>
           <a:p>
-            <a:pPr indent="0" marL="0">
+            <a:pPr marL="0" indent="0">
               <a:buNone/>
             </a:pPr>
             <a:r>
@@ -4025,7 +3941,7 @@
           <a:bodyPr wrap="square" lIns="0" tIns="0" rIns="0" bIns="0" rtlCol="0" anchor="ctr"/>
           <a:lstStyle/>
           <a:p>
-            <a:pPr indent="0" marL="0">
+            <a:pPr marL="0" indent="0">
               <a:lnSpc>
                 <a:spcPct val="100000"/>
               </a:lnSpc>
@@ -4067,6 +3983,13 @@
           </a:solidFill>
           <a:ln/>
         </p:spPr>
+        <p:txBody>
+          <a:bodyPr/>
+          <a:lstStyle/>
+          <a:p>
+            <a:endParaRPr lang="es-ES"/>
+          </a:p>
+        </p:txBody>
       </p:sp>
       <p:sp>
         <p:nvSpPr>
@@ -4089,7 +4012,7 @@
           <a:bodyPr wrap="square" lIns="0" tIns="0" rIns="0" bIns="0" rtlCol="0" anchor="ctr"/>
           <a:lstStyle/>
           <a:p>
-            <a:pPr indent="0" marL="0">
+            <a:pPr marL="0" indent="0">
               <a:buNone/>
             </a:pPr>
             <a:r>
@@ -4128,7 +4051,7 @@
           <a:bodyPr wrap="square" lIns="0" tIns="0" rIns="0" bIns="0" rtlCol="0" anchor="ctr"/>
           <a:lstStyle/>
           <a:p>
-            <a:pPr indent="0" marL="0">
+            <a:pPr marL="0" indent="0">
               <a:lnSpc>
                 <a:spcPct val="100000"/>
               </a:lnSpc>
@@ -4170,6 +4093,13 @@
           </a:solidFill>
           <a:ln/>
         </p:spPr>
+        <p:txBody>
+          <a:bodyPr/>
+          <a:lstStyle/>
+          <a:p>
+            <a:endParaRPr lang="es-ES"/>
+          </a:p>
+        </p:txBody>
       </p:sp>
       <p:sp>
         <p:nvSpPr>
@@ -4192,7 +4122,7 @@
           <a:bodyPr wrap="square" lIns="0" tIns="0" rIns="0" bIns="0" rtlCol="0" anchor="ctr"/>
           <a:lstStyle/>
           <a:p>
-            <a:pPr indent="0" marL="0">
+            <a:pPr marL="0" indent="0">
               <a:buNone/>
             </a:pPr>
             <a:r>
@@ -4231,7 +4161,7 @@
           <a:bodyPr wrap="square" lIns="0" tIns="0" rIns="0" bIns="0" rtlCol="0" anchor="ctr"/>
           <a:lstStyle/>
           <a:p>
-            <a:pPr indent="0" marL="0">
+            <a:pPr marL="0" indent="0">
               <a:lnSpc>
                 <a:spcPct val="100000"/>
               </a:lnSpc>
@@ -4273,6 +4203,13 @@
           </a:solidFill>
           <a:ln/>
         </p:spPr>
+        <p:txBody>
+          <a:bodyPr/>
+          <a:lstStyle/>
+          <a:p>
+            <a:endParaRPr lang="es-ES"/>
+          </a:p>
+        </p:txBody>
       </p:sp>
       <p:sp>
         <p:nvSpPr>
@@ -4295,7 +4232,7 @@
           <a:bodyPr wrap="square" lIns="0" tIns="0" rIns="0" bIns="0" rtlCol="0" anchor="ctr"/>
           <a:lstStyle/>
           <a:p>
-            <a:pPr indent="0" marL="0">
+            <a:pPr marL="0" indent="0">
               <a:buNone/>
             </a:pPr>
             <a:r>
@@ -4334,7 +4271,7 @@
           <a:bodyPr wrap="square" lIns="0" tIns="0" rIns="0" bIns="0" rtlCol="0" anchor="ctr"/>
           <a:lstStyle/>
           <a:p>
-            <a:pPr indent="0" marL="0">
+            <a:pPr marL="0" indent="0">
               <a:lnSpc>
                 <a:spcPct val="100000"/>
               </a:lnSpc>
@@ -4376,6 +4313,13 @@
           </a:solidFill>
           <a:ln/>
         </p:spPr>
+        <p:txBody>
+          <a:bodyPr/>
+          <a:lstStyle/>
+          <a:p>
+            <a:endParaRPr lang="es-ES"/>
+          </a:p>
+        </p:txBody>
       </p:sp>
       <p:sp>
         <p:nvSpPr>
@@ -4398,7 +4342,7 @@
           <a:bodyPr wrap="square" lIns="0" tIns="0" rIns="0" bIns="0" rtlCol="0" anchor="ctr"/>
           <a:lstStyle/>
           <a:p>
-            <a:pPr indent="0" marL="0">
+            <a:pPr marL="0" indent="0">
               <a:buNone/>
             </a:pPr>
             <a:r>
@@ -4412,9 +4356,6 @@
               </a:rPr>
               <a:t>Evidencia titular:  </a:t>
             </a:r>
-            <a:pPr indent="0" marL="0">
-              <a:buNone/>
-            </a:pPr>
             <a:r>
               <a:rPr lang="en-US" sz="1400" b="1" dirty="0">
                 <a:solidFill>
@@ -4426,9 +4367,6 @@
               </a:rPr>
               <a:t>suite verde en CI contra PostgreSQL real + Playwright.  </a:t>
             </a:r>
-            <a:pPr indent="0" marL="0">
-              <a:buNone/>
-            </a:pPr>
             <a:r>
               <a:rPr lang="en-US" sz="1250" i="1" dirty="0">
                 <a:solidFill>
@@ -4465,7 +4403,7 @@
           <a:bodyPr wrap="square" rtlCol="0" anchor="ctr"/>
           <a:lstStyle/>
           <a:p>
-            <a:pPr algn="r" indent="0" marL="0">
+            <a:pPr marL="0" indent="0" algn="r">
               <a:buNone/>
             </a:pPr>
             <a:r>
@@ -4499,6 +4437,7 @@
         <a:solidFill>
           <a:srgbClr val="F5F5F2"/>
         </a:solidFill>
+        <a:effectLst/>
       </p:bgPr>
     </p:bg>
     <p:spTree>
@@ -4536,11 +4475,11 @@
           <a:bodyPr wrap="square" lIns="0" tIns="0" rIns="0" bIns="0" rtlCol="0" anchor="ctr"/>
           <a:lstStyle/>
           <a:p>
-            <a:pPr indent="0" marL="0">
-              <a:buNone/>
-            </a:pPr>
-            <a:r>
-              <a:rPr lang="en-US" sz="1200" b="1" spc="300" kern="0" dirty="0">
+            <a:pPr marL="0" indent="0">
+              <a:buNone/>
+            </a:pPr>
+            <a:r>
+              <a:rPr lang="en-US" sz="1200" b="1" kern="0" spc="300" dirty="0">
                 <a:solidFill>
                   <a:srgbClr val="69A297"/>
                 </a:solidFill>
@@ -4575,7 +4514,7 @@
           <a:bodyPr wrap="square" lIns="0" tIns="0" rIns="0" bIns="0" rtlCol="0" anchor="ctr"/>
           <a:lstStyle/>
           <a:p>
-            <a:pPr indent="0" marL="0">
+            <a:pPr marL="0" indent="0">
               <a:lnSpc>
                 <a:spcPct val="98000"/>
               </a:lnSpc>
@@ -4617,13 +4556,20 @@
           </a:solidFill>
           <a:ln/>
           <a:effectLst>
-            <a:outerShdw sx="100000" sy="100000" kx="0" ky="0" algn="bl" rotWithShape="0" blurRad="101600" dist="38100" dir="5400000">
+            <a:outerShdw blurRad="101600" dist="38100" dir="5400000" algn="bl" rotWithShape="0">
               <a:srgbClr val="9AA8A5">
                 <a:alpha val="28000"/>
               </a:srgbClr>
             </a:outerShdw>
           </a:effectLst>
         </p:spPr>
+        <p:txBody>
+          <a:bodyPr/>
+          <a:lstStyle/>
+          <a:p>
+            <a:endParaRPr lang="es-ES"/>
+          </a:p>
+        </p:txBody>
       </p:sp>
       <p:sp>
         <p:nvSpPr>
@@ -4644,6 +4590,13 @@
           </a:solidFill>
           <a:ln/>
         </p:spPr>
+        <p:txBody>
+          <a:bodyPr/>
+          <a:lstStyle/>
+          <a:p>
+            <a:endParaRPr lang="es-ES"/>
+          </a:p>
+        </p:txBody>
       </p:sp>
       <p:sp>
         <p:nvSpPr>
@@ -4666,7 +4619,7 @@
           <a:bodyPr wrap="square" lIns="0" tIns="0" rIns="0" bIns="0" rtlCol="0" anchor="ctr"/>
           <a:lstStyle/>
           <a:p>
-            <a:pPr indent="0" marL="0">
+            <a:pPr marL="0" indent="0">
               <a:buNone/>
             </a:pPr>
             <a:r>
@@ -4790,13 +4743,20 @@
           </a:solidFill>
           <a:ln/>
           <a:effectLst>
-            <a:outerShdw sx="100000" sy="100000" kx="0" ky="0" algn="bl" rotWithShape="0" blurRad="101600" dist="38100" dir="5400000">
+            <a:outerShdw blurRad="101600" dist="38100" dir="5400000" algn="bl" rotWithShape="0">
               <a:srgbClr val="9AA8A5">
                 <a:alpha val="28000"/>
               </a:srgbClr>
             </a:outerShdw>
           </a:effectLst>
         </p:spPr>
+        <p:txBody>
+          <a:bodyPr/>
+          <a:lstStyle/>
+          <a:p>
+            <a:endParaRPr lang="es-ES"/>
+          </a:p>
+        </p:txBody>
       </p:sp>
       <p:sp>
         <p:nvSpPr>
@@ -4817,6 +4777,13 @@
           </a:solidFill>
           <a:ln/>
         </p:spPr>
+        <p:txBody>
+          <a:bodyPr/>
+          <a:lstStyle/>
+          <a:p>
+            <a:endParaRPr lang="es-ES"/>
+          </a:p>
+        </p:txBody>
       </p:sp>
       <p:sp>
         <p:nvSpPr>
@@ -4839,7 +4806,7 @@
           <a:bodyPr wrap="square" lIns="0" tIns="0" rIns="0" bIns="0" rtlCol="0" anchor="ctr"/>
           <a:lstStyle/>
           <a:p>
-            <a:pPr indent="0" marL="0">
+            <a:pPr marL="0" indent="0">
               <a:buNone/>
             </a:pPr>
             <a:r>
@@ -4963,13 +4930,20 @@
           </a:solidFill>
           <a:ln/>
           <a:effectLst>
-            <a:outerShdw sx="100000" sy="100000" kx="0" ky="0" algn="bl" rotWithShape="0" blurRad="101600" dist="38100" dir="5400000">
+            <a:outerShdw blurRad="101600" dist="38100" dir="5400000" algn="bl" rotWithShape="0">
               <a:srgbClr val="9AA8A5">
                 <a:alpha val="28000"/>
               </a:srgbClr>
             </a:outerShdw>
           </a:effectLst>
         </p:spPr>
+        <p:txBody>
+          <a:bodyPr/>
+          <a:lstStyle/>
+          <a:p>
+            <a:endParaRPr lang="es-ES"/>
+          </a:p>
+        </p:txBody>
       </p:sp>
       <p:sp>
         <p:nvSpPr>
@@ -4990,6 +4964,13 @@
           </a:solidFill>
           <a:ln/>
         </p:spPr>
+        <p:txBody>
+          <a:bodyPr/>
+          <a:lstStyle/>
+          <a:p>
+            <a:endParaRPr lang="es-ES"/>
+          </a:p>
+        </p:txBody>
       </p:sp>
       <p:sp>
         <p:nvSpPr>
@@ -5012,7 +4993,7 @@
           <a:bodyPr wrap="square" lIns="0" tIns="0" rIns="0" bIns="0" rtlCol="0" anchor="ctr"/>
           <a:lstStyle/>
           <a:p>
-            <a:pPr indent="0" marL="0">
+            <a:pPr marL="0" indent="0">
               <a:buNone/>
             </a:pPr>
             <a:r>
@@ -5141,6 +5122,13 @@
             <a:prstDash val="solid"/>
           </a:ln>
         </p:spPr>
+        <p:txBody>
+          <a:bodyPr/>
+          <a:lstStyle/>
+          <a:p>
+            <a:endParaRPr lang="es-ES"/>
+          </a:p>
+        </p:txBody>
       </p:sp>
       <p:sp>
         <p:nvSpPr>
@@ -5163,7 +5151,7 @@
           <a:bodyPr wrap="square" lIns="0" tIns="0" rIns="0" bIns="0" rtlCol="0" anchor="ctr"/>
           <a:lstStyle/>
           <a:p>
-            <a:pPr indent="0" marL="0">
+            <a:pPr marL="0" indent="0">
               <a:lnSpc>
                 <a:spcPct val="102000"/>
               </a:lnSpc>
@@ -5180,12 +5168,6 @@
               </a:rPr>
               <a:t>Riesgo aceptado y documentado (T-22):  </a:t>
             </a:r>
-            <a:pPr indent="0" marL="0">
-              <a:lnSpc>
-                <a:spcPct val="102000"/>
-              </a:lnSpc>
-              <a:buNone/>
-            </a:pPr>
             <a:r>
               <a:rPr lang="en-US" sz="1200" dirty="0">
                 <a:solidFill>
@@ -5222,7 +5204,7 @@
           <a:bodyPr wrap="square" rtlCol="0" anchor="ctr"/>
           <a:lstStyle/>
           <a:p>
-            <a:pPr algn="r" indent="0" marL="0">
+            <a:pPr marL="0" indent="0" algn="r">
               <a:buNone/>
             </a:pPr>
             <a:r>
@@ -5256,6 +5238,7 @@
         <a:solidFill>
           <a:srgbClr val="F5F5F2"/>
         </a:solidFill>
+        <a:effectLst/>
       </p:bgPr>
     </p:bg>
     <p:spTree>
@@ -5293,11 +5276,11 @@
           <a:bodyPr wrap="square" lIns="0" tIns="0" rIns="0" bIns="0" rtlCol="0" anchor="ctr"/>
           <a:lstStyle/>
           <a:p>
-            <a:pPr indent="0" marL="0">
-              <a:buNone/>
-            </a:pPr>
-            <a:r>
-              <a:rPr lang="en-US" sz="1200" b="1" spc="300" kern="0" dirty="0">
+            <a:pPr marL="0" indent="0">
+              <a:buNone/>
+            </a:pPr>
+            <a:r>
+              <a:rPr lang="en-US" sz="1200" b="1" kern="0" spc="300" dirty="0">
                 <a:solidFill>
                   <a:srgbClr val="69A297"/>
                 </a:solidFill>
@@ -5332,7 +5315,7 @@
           <a:bodyPr wrap="square" lIns="0" tIns="0" rIns="0" bIns="0" rtlCol="0" anchor="ctr"/>
           <a:lstStyle/>
           <a:p>
-            <a:pPr indent="0" marL="0">
+            <a:pPr marL="0" indent="0">
               <a:lnSpc>
                 <a:spcPct val="98000"/>
               </a:lnSpc>
@@ -5372,6 +5355,13 @@
           </a:solidFill>
           <a:ln/>
         </p:spPr>
+        <p:txBody>
+          <a:bodyPr/>
+          <a:lstStyle/>
+          <a:p>
+            <a:endParaRPr lang="es-ES"/>
+          </a:p>
+        </p:txBody>
       </p:sp>
       <p:sp>
         <p:nvSpPr>
@@ -5394,7 +5384,7 @@
           <a:bodyPr wrap="square" lIns="0" tIns="0" rIns="0" bIns="0" rtlCol="0" anchor="ctr"/>
           <a:lstStyle/>
           <a:p>
-            <a:pPr algn="ctr" indent="0" marL="0">
+            <a:pPr marL="0" indent="0" algn="ctr">
               <a:buNone/>
             </a:pPr>
             <a:r>
@@ -5433,7 +5423,7 @@
           <a:bodyPr wrap="square" lIns="0" tIns="0" rIns="0" bIns="0" rtlCol="0" anchor="ctr"/>
           <a:lstStyle/>
           <a:p>
-            <a:pPr indent="0" marL="0">
+            <a:pPr marL="0" indent="0">
               <a:buNone/>
             </a:pPr>
             <a:r>
@@ -5470,6 +5460,13 @@
           </a:solidFill>
           <a:ln/>
         </p:spPr>
+        <p:txBody>
+          <a:bodyPr/>
+          <a:lstStyle/>
+          <a:p>
+            <a:endParaRPr lang="es-ES"/>
+          </a:p>
+        </p:txBody>
       </p:sp>
       <p:sp>
         <p:nvSpPr>
@@ -5492,7 +5489,7 @@
           <a:bodyPr wrap="square" lIns="0" tIns="0" rIns="0" bIns="0" rtlCol="0" anchor="ctr"/>
           <a:lstStyle/>
           <a:p>
-            <a:pPr algn="ctr" indent="0" marL="0">
+            <a:pPr marL="0" indent="0" algn="ctr">
               <a:buNone/>
             </a:pPr>
             <a:r>
@@ -5531,7 +5528,7 @@
           <a:bodyPr wrap="square" lIns="0" tIns="0" rIns="0" bIns="0" rtlCol="0" anchor="ctr"/>
           <a:lstStyle/>
           <a:p>
-            <a:pPr indent="0" marL="0">
+            <a:pPr marL="0" indent="0">
               <a:buNone/>
             </a:pPr>
             <a:r>
@@ -5568,6 +5565,13 @@
           </a:solidFill>
           <a:ln/>
         </p:spPr>
+        <p:txBody>
+          <a:bodyPr/>
+          <a:lstStyle/>
+          <a:p>
+            <a:endParaRPr lang="es-ES"/>
+          </a:p>
+        </p:txBody>
       </p:sp>
       <p:sp>
         <p:nvSpPr>
@@ -5590,7 +5594,7 @@
           <a:bodyPr wrap="square" lIns="0" tIns="0" rIns="0" bIns="0" rtlCol="0" anchor="ctr"/>
           <a:lstStyle/>
           <a:p>
-            <a:pPr algn="ctr" indent="0" marL="0">
+            <a:pPr marL="0" indent="0" algn="ctr">
               <a:buNone/>
             </a:pPr>
             <a:r>
@@ -5629,7 +5633,7 @@
           <a:bodyPr wrap="square" lIns="0" tIns="0" rIns="0" bIns="0" rtlCol="0" anchor="ctr"/>
           <a:lstStyle/>
           <a:p>
-            <a:pPr indent="0" marL="0">
+            <a:pPr marL="0" indent="0">
               <a:buNone/>
             </a:pPr>
             <a:r>
@@ -5666,6 +5670,13 @@
           </a:solidFill>
           <a:ln/>
         </p:spPr>
+        <p:txBody>
+          <a:bodyPr/>
+          <a:lstStyle/>
+          <a:p>
+            <a:endParaRPr lang="es-ES"/>
+          </a:p>
+        </p:txBody>
       </p:sp>
       <p:sp>
         <p:nvSpPr>
@@ -5688,7 +5699,7 @@
           <a:bodyPr wrap="square" lIns="0" tIns="0" rIns="0" bIns="0" rtlCol="0" anchor="ctr"/>
           <a:lstStyle/>
           <a:p>
-            <a:pPr algn="ctr" indent="0" marL="0">
+            <a:pPr marL="0" indent="0" algn="ctr">
               <a:buNone/>
             </a:pPr>
             <a:r>
@@ -5727,7 +5738,7 @@
           <a:bodyPr wrap="square" lIns="0" tIns="0" rIns="0" bIns="0" rtlCol="0" anchor="ctr"/>
           <a:lstStyle/>
           <a:p>
-            <a:pPr indent="0" marL="0">
+            <a:pPr marL="0" indent="0">
               <a:buNone/>
             </a:pPr>
             <a:r>
@@ -5764,6 +5775,13 @@
           </a:solidFill>
           <a:ln/>
         </p:spPr>
+        <p:txBody>
+          <a:bodyPr/>
+          <a:lstStyle/>
+          <a:p>
+            <a:endParaRPr lang="es-ES"/>
+          </a:p>
+        </p:txBody>
       </p:sp>
       <p:sp>
         <p:nvSpPr>
@@ -5786,7 +5804,7 @@
           <a:bodyPr wrap="square" lIns="0" tIns="0" rIns="0" bIns="0" rtlCol="0" anchor="ctr"/>
           <a:lstStyle/>
           <a:p>
-            <a:pPr algn="ctr" indent="0" marL="0">
+            <a:pPr marL="0" indent="0" algn="ctr">
               <a:buNone/>
             </a:pPr>
             <a:r>
@@ -5825,7 +5843,7 @@
           <a:bodyPr wrap="square" lIns="0" tIns="0" rIns="0" bIns="0" rtlCol="0" anchor="ctr"/>
           <a:lstStyle/>
           <a:p>
-            <a:pPr indent="0" marL="0">
+            <a:pPr marL="0" indent="0">
               <a:buNone/>
             </a:pPr>
             <a:r>
@@ -5862,6 +5880,13 @@
           </a:solidFill>
           <a:ln/>
         </p:spPr>
+        <p:txBody>
+          <a:bodyPr/>
+          <a:lstStyle/>
+          <a:p>
+            <a:endParaRPr lang="es-ES"/>
+          </a:p>
+        </p:txBody>
       </p:sp>
       <p:sp>
         <p:nvSpPr>
@@ -5884,7 +5909,7 @@
           <a:bodyPr wrap="square" lIns="0" tIns="0" rIns="0" bIns="0" rtlCol="0" anchor="ctr"/>
           <a:lstStyle/>
           <a:p>
-            <a:pPr algn="ctr" indent="0" marL="0">
+            <a:pPr marL="0" indent="0" algn="ctr">
               <a:buNone/>
             </a:pPr>
             <a:r>
@@ -5923,7 +5948,7 @@
           <a:bodyPr wrap="square" lIns="0" tIns="0" rIns="0" bIns="0" rtlCol="0" anchor="ctr"/>
           <a:lstStyle/>
           <a:p>
-            <a:pPr indent="0" marL="0">
+            <a:pPr marL="0" indent="0">
               <a:buNone/>
             </a:pPr>
             <a:r>
@@ -5962,6 +5987,13 @@
           </a:solidFill>
           <a:ln/>
         </p:spPr>
+        <p:txBody>
+          <a:bodyPr/>
+          <a:lstStyle/>
+          <a:p>
+            <a:endParaRPr lang="es-ES"/>
+          </a:p>
+        </p:txBody>
       </p:sp>
       <p:sp>
         <p:nvSpPr>
@@ -5984,7 +6016,7 @@
           <a:bodyPr wrap="square" lIns="0" tIns="0" rIns="0" bIns="0" rtlCol="0" anchor="ctr"/>
           <a:lstStyle/>
           <a:p>
-            <a:pPr indent="0" marL="0">
+            <a:pPr marL="0" indent="0">
               <a:buNone/>
             </a:pPr>
             <a:r>
@@ -6023,7 +6055,7 @@
           <a:bodyPr wrap="square" lIns="0" tIns="0" rIns="0" bIns="0" rtlCol="0" anchor="ctr"/>
           <a:lstStyle/>
           <a:p>
-            <a:pPr indent="0" marL="0">
+            <a:pPr marL="0" indent="0">
               <a:lnSpc>
                 <a:spcPct val="112000"/>
               </a:lnSpc>
@@ -6065,7 +6097,7 @@
           <a:bodyPr wrap="square" lIns="0" tIns="0" rIns="0" bIns="0" rtlCol="0" anchor="ctr"/>
           <a:lstStyle/>
           <a:p>
-            <a:pPr indent="0" marL="0">
+            <a:pPr marL="0" indent="0">
               <a:lnSpc>
                 <a:spcPct val="105000"/>
               </a:lnSpc>
@@ -6107,7 +6139,7 @@
           <a:bodyPr wrap="square" rtlCol="0" anchor="ctr"/>
           <a:lstStyle/>
           <a:p>
-            <a:pPr algn="r" indent="0" marL="0">
+            <a:pPr marL="0" indent="0" algn="r">
               <a:buNone/>
             </a:pPr>
             <a:r>
@@ -6141,6 +6173,7 @@
         <a:solidFill>
           <a:srgbClr val="F5F5F2"/>
         </a:solidFill>
+        <a:effectLst/>
       </p:bgPr>
     </p:bg>
     <p:spTree>
@@ -6178,11 +6211,11 @@
           <a:bodyPr wrap="square" lIns="0" tIns="0" rIns="0" bIns="0" rtlCol="0" anchor="ctr"/>
           <a:lstStyle/>
           <a:p>
-            <a:pPr indent="0" marL="0">
-              <a:buNone/>
-            </a:pPr>
-            <a:r>
-              <a:rPr lang="en-US" sz="1200" b="1" spc="300" kern="0" dirty="0">
+            <a:pPr marL="0" indent="0">
+              <a:buNone/>
+            </a:pPr>
+            <a:r>
+              <a:rPr lang="en-US" sz="1200" b="1" kern="0" spc="300" dirty="0">
                 <a:solidFill>
                   <a:srgbClr val="69A297"/>
                 </a:solidFill>
@@ -6217,7 +6250,7 @@
           <a:bodyPr wrap="square" lIns="0" tIns="0" rIns="0" bIns="0" rtlCol="0" anchor="ctr"/>
           <a:lstStyle/>
           <a:p>
-            <a:pPr indent="0" marL="0">
+            <a:pPr marL="0" indent="0">
               <a:lnSpc>
                 <a:spcPct val="98000"/>
               </a:lnSpc>
@@ -6259,13 +6292,20 @@
           </a:solidFill>
           <a:ln/>
           <a:effectLst>
-            <a:outerShdw sx="100000" sy="100000" kx="0" ky="0" algn="bl" rotWithShape="0" blurRad="101600" dist="38100" dir="5400000">
+            <a:outerShdw blurRad="101600" dist="38100" dir="5400000" algn="bl" rotWithShape="0">
               <a:srgbClr val="9AA8A5">
                 <a:alpha val="28000"/>
               </a:srgbClr>
             </a:outerShdw>
           </a:effectLst>
         </p:spPr>
+        <p:txBody>
+          <a:bodyPr/>
+          <a:lstStyle/>
+          <a:p>
+            <a:endParaRPr lang="es-ES"/>
+          </a:p>
+        </p:txBody>
       </p:sp>
       <p:sp>
         <p:nvSpPr>
@@ -6288,6 +6328,13 @@
           </a:solidFill>
           <a:ln/>
         </p:spPr>
+        <p:txBody>
+          <a:bodyPr/>
+          <a:lstStyle/>
+          <a:p>
+            <a:endParaRPr lang="es-ES"/>
+          </a:p>
+        </p:txBody>
       </p:sp>
       <p:sp>
         <p:nvSpPr>
@@ -6310,7 +6357,7 @@
           <a:bodyPr wrap="square" lIns="0" tIns="0" rIns="0" bIns="0" rtlCol="0" anchor="ctr"/>
           <a:lstStyle/>
           <a:p>
-            <a:pPr indent="0" marL="0">
+            <a:pPr marL="0" indent="0">
               <a:lnSpc>
                 <a:spcPct val="95000"/>
               </a:lnSpc>
@@ -6500,13 +6547,20 @@
           </a:solidFill>
           <a:ln/>
           <a:effectLst>
-            <a:outerShdw sx="100000" sy="100000" kx="0" ky="0" algn="bl" rotWithShape="0" blurRad="101600" dist="38100" dir="5400000">
+            <a:outerShdw blurRad="101600" dist="38100" dir="5400000" algn="bl" rotWithShape="0">
               <a:srgbClr val="9AA8A5">
                 <a:alpha val="28000"/>
               </a:srgbClr>
             </a:outerShdw>
           </a:effectLst>
         </p:spPr>
+        <p:txBody>
+          <a:bodyPr/>
+          <a:lstStyle/>
+          <a:p>
+            <a:endParaRPr lang="es-ES"/>
+          </a:p>
+        </p:txBody>
       </p:sp>
       <p:sp>
         <p:nvSpPr>
@@ -6529,6 +6583,13 @@
           </a:solidFill>
           <a:ln/>
         </p:spPr>
+        <p:txBody>
+          <a:bodyPr/>
+          <a:lstStyle/>
+          <a:p>
+            <a:endParaRPr lang="es-ES"/>
+          </a:p>
+        </p:txBody>
       </p:sp>
       <p:sp>
         <p:nvSpPr>
@@ -6551,7 +6612,7 @@
           <a:bodyPr wrap="square" lIns="0" tIns="0" rIns="0" bIns="0" rtlCol="0" anchor="ctr"/>
           <a:lstStyle/>
           <a:p>
-            <a:pPr indent="0" marL="0">
+            <a:pPr marL="0" indent="0">
               <a:lnSpc>
                 <a:spcPct val="95000"/>
               </a:lnSpc>
@@ -6699,13 +6760,20 @@
           </a:solidFill>
           <a:ln/>
           <a:effectLst>
-            <a:outerShdw sx="100000" sy="100000" kx="0" ky="0" algn="bl" rotWithShape="0" blurRad="101600" dist="38100" dir="5400000">
+            <a:outerShdw blurRad="101600" dist="38100" dir="5400000" algn="bl" rotWithShape="0">
               <a:srgbClr val="9AA8A5">
                 <a:alpha val="28000"/>
               </a:srgbClr>
             </a:outerShdw>
           </a:effectLst>
         </p:spPr>
+        <p:txBody>
+          <a:bodyPr/>
+          <a:lstStyle/>
+          <a:p>
+            <a:endParaRPr lang="es-ES"/>
+          </a:p>
+        </p:txBody>
       </p:sp>
       <p:sp>
         <p:nvSpPr>
@@ -6728,6 +6796,13 @@
           </a:solidFill>
           <a:ln/>
         </p:spPr>
+        <p:txBody>
+          <a:bodyPr/>
+          <a:lstStyle/>
+          <a:p>
+            <a:endParaRPr lang="es-ES"/>
+          </a:p>
+        </p:txBody>
       </p:sp>
       <p:sp>
         <p:nvSpPr>
@@ -6750,7 +6825,7 @@
           <a:bodyPr wrap="square" lIns="0" tIns="0" rIns="0" bIns="0" rtlCol="0" anchor="ctr"/>
           <a:lstStyle/>
           <a:p>
-            <a:pPr indent="0" marL="0">
+            <a:pPr marL="0" indent="0">
               <a:lnSpc>
                 <a:spcPct val="95000"/>
               </a:lnSpc>
@@ -6898,7 +6973,7 @@
           <a:bodyPr wrap="square" lIns="0" tIns="0" rIns="0" bIns="0" rtlCol="0" anchor="ctr"/>
           <a:lstStyle/>
           <a:p>
-            <a:pPr indent="0" marL="0">
+            <a:pPr marL="0" indent="0">
               <a:buNone/>
             </a:pPr>
             <a:r>
@@ -6937,7 +7012,7 @@
           <a:bodyPr wrap="square" rtlCol="0" anchor="ctr"/>
           <a:lstStyle/>
           <a:p>
-            <a:pPr algn="r" indent="0" marL="0">
+            <a:pPr marL="0" indent="0" algn="r">
               <a:buNone/>
             </a:pPr>
             <a:r>
@@ -6971,6 +7046,7 @@
         <a:solidFill>
           <a:srgbClr val="F5F5F2"/>
         </a:solidFill>
+        <a:effectLst/>
       </p:bgPr>
     </p:bg>
     <p:spTree>
@@ -7008,11 +7084,11 @@
           <a:bodyPr wrap="square" lIns="0" tIns="0" rIns="0" bIns="0" rtlCol="0" anchor="ctr"/>
           <a:lstStyle/>
           <a:p>
-            <a:pPr indent="0" marL="0">
-              <a:buNone/>
-            </a:pPr>
-            <a:r>
-              <a:rPr lang="en-US" sz="1200" b="1" spc="300" kern="0" dirty="0">
+            <a:pPr marL="0" indent="0">
+              <a:buNone/>
+            </a:pPr>
+            <a:r>
+              <a:rPr lang="en-US" sz="1200" b="1" kern="0" spc="300" dirty="0">
                 <a:solidFill>
                   <a:srgbClr val="69A297"/>
                 </a:solidFill>
@@ -7047,7 +7123,7 @@
           <a:bodyPr wrap="square" lIns="0" tIns="0" rIns="0" bIns="0" rtlCol="0" anchor="ctr"/>
           <a:lstStyle/>
           <a:p>
-            <a:pPr indent="0" marL="0">
+            <a:pPr marL="0" indent="0">
               <a:lnSpc>
                 <a:spcPct val="98000"/>
               </a:lnSpc>
@@ -7089,13 +7165,20 @@
           </a:solidFill>
           <a:ln/>
           <a:effectLst>
-            <a:outerShdw sx="100000" sy="100000" kx="0" ky="0" algn="bl" rotWithShape="0" blurRad="101600" dist="38100" dir="5400000">
+            <a:outerShdw blurRad="101600" dist="38100" dir="5400000" algn="bl" rotWithShape="0">
               <a:srgbClr val="9AA8A5">
                 <a:alpha val="28000"/>
               </a:srgbClr>
             </a:outerShdw>
           </a:effectLst>
         </p:spPr>
+        <p:txBody>
+          <a:bodyPr/>
+          <a:lstStyle/>
+          <a:p>
+            <a:endParaRPr lang="es-ES"/>
+          </a:p>
+        </p:txBody>
       </p:sp>
       <p:sp>
         <p:nvSpPr>
@@ -7116,6 +7199,13 @@
           </a:solidFill>
           <a:ln/>
         </p:spPr>
+        <p:txBody>
+          <a:bodyPr/>
+          <a:lstStyle/>
+          <a:p>
+            <a:endParaRPr lang="es-ES"/>
+          </a:p>
+        </p:txBody>
       </p:sp>
       <p:sp>
         <p:nvSpPr>
@@ -7138,7 +7228,7 @@
           <a:bodyPr wrap="square" lIns="0" tIns="0" rIns="0" bIns="0" rtlCol="0" anchor="ctr"/>
           <a:lstStyle/>
           <a:p>
-            <a:pPr algn="ctr" indent="0" marL="0">
+            <a:pPr marL="0" indent="0" algn="ctr">
               <a:buNone/>
             </a:pPr>
             <a:r>
@@ -7177,7 +7267,7 @@
           <a:bodyPr wrap="square" lIns="0" tIns="0" rIns="0" bIns="0" rtlCol="0" anchor="ctr"/>
           <a:lstStyle/>
           <a:p>
-            <a:pPr indent="0" marL="0">
+            <a:pPr marL="0" indent="0">
               <a:buNone/>
             </a:pPr>
             <a:r>
@@ -7216,7 +7306,7 @@
           <a:bodyPr wrap="square" lIns="0" tIns="0" rIns="0" bIns="0" rtlCol="0" anchor="ctr"/>
           <a:lstStyle/>
           <a:p>
-            <a:pPr indent="0" marL="0">
+            <a:pPr marL="0" indent="0">
               <a:lnSpc>
                 <a:spcPct val="102000"/>
               </a:lnSpc>
@@ -7258,13 +7348,20 @@
           </a:solidFill>
           <a:ln/>
           <a:effectLst>
-            <a:outerShdw sx="100000" sy="100000" kx="0" ky="0" algn="bl" rotWithShape="0" blurRad="101600" dist="38100" dir="5400000">
+            <a:outerShdw blurRad="101600" dist="38100" dir="5400000" algn="bl" rotWithShape="0">
               <a:srgbClr val="9AA8A5">
                 <a:alpha val="28000"/>
               </a:srgbClr>
             </a:outerShdw>
           </a:effectLst>
         </p:spPr>
+        <p:txBody>
+          <a:bodyPr/>
+          <a:lstStyle/>
+          <a:p>
+            <a:endParaRPr lang="es-ES"/>
+          </a:p>
+        </p:txBody>
       </p:sp>
       <p:sp>
         <p:nvSpPr>
@@ -7285,6 +7382,13 @@
           </a:solidFill>
           <a:ln/>
         </p:spPr>
+        <p:txBody>
+          <a:bodyPr/>
+          <a:lstStyle/>
+          <a:p>
+            <a:endParaRPr lang="es-ES"/>
+          </a:p>
+        </p:txBody>
       </p:sp>
       <p:sp>
         <p:nvSpPr>
@@ -7307,7 +7411,7 @@
           <a:bodyPr wrap="square" lIns="0" tIns="0" rIns="0" bIns="0" rtlCol="0" anchor="ctr"/>
           <a:lstStyle/>
           <a:p>
-            <a:pPr algn="ctr" indent="0" marL="0">
+            <a:pPr marL="0" indent="0" algn="ctr">
               <a:buNone/>
             </a:pPr>
             <a:r>
@@ -7346,7 +7450,7 @@
           <a:bodyPr wrap="square" lIns="0" tIns="0" rIns="0" bIns="0" rtlCol="0" anchor="ctr"/>
           <a:lstStyle/>
           <a:p>
-            <a:pPr indent="0" marL="0">
+            <a:pPr marL="0" indent="0">
               <a:buNone/>
             </a:pPr>
             <a:r>
@@ -7385,7 +7489,7 @@
           <a:bodyPr wrap="square" lIns="0" tIns="0" rIns="0" bIns="0" rtlCol="0" anchor="ctr"/>
           <a:lstStyle/>
           <a:p>
-            <a:pPr indent="0" marL="0">
+            <a:pPr marL="0" indent="0">
               <a:lnSpc>
                 <a:spcPct val="102000"/>
               </a:lnSpc>
@@ -7427,13 +7531,20 @@
           </a:solidFill>
           <a:ln/>
           <a:effectLst>
-            <a:outerShdw sx="100000" sy="100000" kx="0" ky="0" algn="bl" rotWithShape="0" blurRad="101600" dist="38100" dir="5400000">
+            <a:outerShdw blurRad="101600" dist="38100" dir="5400000" algn="bl" rotWithShape="0">
               <a:srgbClr val="9AA8A5">
                 <a:alpha val="28000"/>
               </a:srgbClr>
             </a:outerShdw>
           </a:effectLst>
         </p:spPr>
+        <p:txBody>
+          <a:bodyPr/>
+          <a:lstStyle/>
+          <a:p>
+            <a:endParaRPr lang="es-ES"/>
+          </a:p>
+        </p:txBody>
       </p:sp>
       <p:sp>
         <p:nvSpPr>
@@ -7454,6 +7565,13 @@
           </a:solidFill>
           <a:ln/>
         </p:spPr>
+        <p:txBody>
+          <a:bodyPr/>
+          <a:lstStyle/>
+          <a:p>
+            <a:endParaRPr lang="es-ES"/>
+          </a:p>
+        </p:txBody>
       </p:sp>
       <p:sp>
         <p:nvSpPr>
@@ -7476,7 +7594,7 @@
           <a:bodyPr wrap="square" lIns="0" tIns="0" rIns="0" bIns="0" rtlCol="0" anchor="ctr"/>
           <a:lstStyle/>
           <a:p>
-            <a:pPr algn="ctr" indent="0" marL="0">
+            <a:pPr marL="0" indent="0" algn="ctr">
               <a:buNone/>
             </a:pPr>
             <a:r>
@@ -7515,7 +7633,7 @@
           <a:bodyPr wrap="square" lIns="0" tIns="0" rIns="0" bIns="0" rtlCol="0" anchor="ctr"/>
           <a:lstStyle/>
           <a:p>
-            <a:pPr indent="0" marL="0">
+            <a:pPr marL="0" indent="0">
               <a:buNone/>
             </a:pPr>
             <a:r>
@@ -7554,7 +7672,7 @@
           <a:bodyPr wrap="square" lIns="0" tIns="0" rIns="0" bIns="0" rtlCol="0" anchor="ctr"/>
           <a:lstStyle/>
           <a:p>
-            <a:pPr indent="0" marL="0">
+            <a:pPr marL="0" indent="0">
               <a:lnSpc>
                 <a:spcPct val="102000"/>
               </a:lnSpc>
@@ -7596,13 +7714,20 @@
           </a:solidFill>
           <a:ln/>
           <a:effectLst>
-            <a:outerShdw sx="100000" sy="100000" kx="0" ky="0" algn="bl" rotWithShape="0" blurRad="101600" dist="38100" dir="5400000">
+            <a:outerShdw blurRad="101600" dist="38100" dir="5400000" algn="bl" rotWithShape="0">
               <a:srgbClr val="9AA8A5">
                 <a:alpha val="28000"/>
               </a:srgbClr>
             </a:outerShdw>
           </a:effectLst>
         </p:spPr>
+        <p:txBody>
+          <a:bodyPr/>
+          <a:lstStyle/>
+          <a:p>
+            <a:endParaRPr lang="es-ES"/>
+          </a:p>
+        </p:txBody>
       </p:sp>
       <p:sp>
         <p:nvSpPr>
@@ -7623,6 +7748,13 @@
           </a:solidFill>
           <a:ln/>
         </p:spPr>
+        <p:txBody>
+          <a:bodyPr/>
+          <a:lstStyle/>
+          <a:p>
+            <a:endParaRPr lang="es-ES"/>
+          </a:p>
+        </p:txBody>
       </p:sp>
       <p:sp>
         <p:nvSpPr>
@@ -7645,7 +7777,7 @@
           <a:bodyPr wrap="square" lIns="0" tIns="0" rIns="0" bIns="0" rtlCol="0" anchor="ctr"/>
           <a:lstStyle/>
           <a:p>
-            <a:pPr algn="ctr" indent="0" marL="0">
+            <a:pPr marL="0" indent="0" algn="ctr">
               <a:buNone/>
             </a:pPr>
             <a:r>
@@ -7684,7 +7816,7 @@
           <a:bodyPr wrap="square" lIns="0" tIns="0" rIns="0" bIns="0" rtlCol="0" anchor="ctr"/>
           <a:lstStyle/>
           <a:p>
-            <a:pPr indent="0" marL="0">
+            <a:pPr marL="0" indent="0">
               <a:buNone/>
             </a:pPr>
             <a:r>
@@ -7723,7 +7855,7 @@
           <a:bodyPr wrap="square" lIns="0" tIns="0" rIns="0" bIns="0" rtlCol="0" anchor="ctr"/>
           <a:lstStyle/>
           <a:p>
-            <a:pPr indent="0" marL="0">
+            <a:pPr marL="0" indent="0">
               <a:lnSpc>
                 <a:spcPct val="102000"/>
               </a:lnSpc>
@@ -7765,13 +7897,20 @@
           </a:solidFill>
           <a:ln/>
           <a:effectLst>
-            <a:outerShdw sx="100000" sy="100000" kx="0" ky="0" algn="bl" rotWithShape="0" blurRad="101600" dist="38100" dir="5400000">
+            <a:outerShdw blurRad="101600" dist="38100" dir="5400000" algn="bl" rotWithShape="0">
               <a:srgbClr val="9AA8A5">
                 <a:alpha val="28000"/>
               </a:srgbClr>
             </a:outerShdw>
           </a:effectLst>
         </p:spPr>
+        <p:txBody>
+          <a:bodyPr/>
+          <a:lstStyle/>
+          <a:p>
+            <a:endParaRPr lang="es-ES"/>
+          </a:p>
+        </p:txBody>
       </p:sp>
       <p:sp>
         <p:nvSpPr>
@@ -7792,6 +7931,13 @@
           </a:solidFill>
           <a:ln/>
         </p:spPr>
+        <p:txBody>
+          <a:bodyPr/>
+          <a:lstStyle/>
+          <a:p>
+            <a:endParaRPr lang="es-ES"/>
+          </a:p>
+        </p:txBody>
       </p:sp>
       <p:sp>
         <p:nvSpPr>
@@ -7814,7 +7960,7 @@
           <a:bodyPr wrap="square" lIns="0" tIns="0" rIns="0" bIns="0" rtlCol="0" anchor="ctr"/>
           <a:lstStyle/>
           <a:p>
-            <a:pPr algn="ctr" indent="0" marL="0">
+            <a:pPr marL="0" indent="0" algn="ctr">
               <a:buNone/>
             </a:pPr>
             <a:r>
@@ -7853,7 +7999,7 @@
           <a:bodyPr wrap="square" lIns="0" tIns="0" rIns="0" bIns="0" rtlCol="0" anchor="ctr"/>
           <a:lstStyle/>
           <a:p>
-            <a:pPr indent="0" marL="0">
+            <a:pPr marL="0" indent="0">
               <a:buNone/>
             </a:pPr>
             <a:r>
@@ -7892,7 +8038,7 @@
           <a:bodyPr wrap="square" lIns="0" tIns="0" rIns="0" bIns="0" rtlCol="0" anchor="ctr"/>
           <a:lstStyle/>
           <a:p>
-            <a:pPr indent="0" marL="0">
+            <a:pPr marL="0" indent="0">
               <a:lnSpc>
                 <a:spcPct val="102000"/>
               </a:lnSpc>
@@ -7934,7 +8080,7 @@
           <a:bodyPr wrap="square" rtlCol="0" anchor="ctr"/>
           <a:lstStyle/>
           <a:p>
-            <a:pPr algn="r" indent="0" marL="0">
+            <a:pPr marL="0" indent="0" algn="r">
               <a:buNone/>
             </a:pPr>
             <a:r>
@@ -7968,6 +8114,7 @@
         <a:solidFill>
           <a:srgbClr val="1E2B2D"/>
         </a:solidFill>
+        <a:effectLst/>
       </p:bgPr>
     </p:bg>
     <p:spTree>
@@ -8005,11 +8152,11 @@
           <a:bodyPr wrap="square" lIns="0" tIns="0" rIns="0" bIns="0" rtlCol="0" anchor="ctr"/>
           <a:lstStyle/>
           <a:p>
-            <a:pPr indent="0" marL="0">
-              <a:buNone/>
-            </a:pPr>
-            <a:r>
-              <a:rPr lang="en-US" sz="1200" b="1" spc="300" kern="0" dirty="0">
+            <a:pPr marL="0" indent="0">
+              <a:buNone/>
+            </a:pPr>
+            <a:r>
+              <a:rPr lang="en-US" sz="1200" b="1" kern="0" spc="300" dirty="0">
                 <a:solidFill>
                   <a:srgbClr val="84B59F"/>
                 </a:solidFill>
@@ -8044,7 +8191,7 @@
           <a:bodyPr wrap="square" lIns="0" tIns="0" rIns="0" bIns="0" rtlCol="0" anchor="ctr"/>
           <a:lstStyle/>
           <a:p>
-            <a:pPr indent="0" marL="0">
+            <a:pPr marL="0" indent="0">
               <a:lnSpc>
                 <a:spcPct val="98000"/>
               </a:lnSpc>
@@ -8213,6 +8360,13 @@
           </a:solidFill>
           <a:ln/>
         </p:spPr>
+        <p:txBody>
+          <a:bodyPr/>
+          <a:lstStyle/>
+          <a:p>
+            <a:endParaRPr lang="es-ES"/>
+          </a:p>
+        </p:txBody>
       </p:sp>
       <p:sp>
         <p:nvSpPr>
@@ -8235,7 +8389,7 @@
           <a:bodyPr wrap="square" lIns="0" tIns="0" rIns="0" bIns="0" rtlCol="0" anchor="ctr"/>
           <a:lstStyle/>
           <a:p>
-            <a:pPr indent="0" marL="0">
+            <a:pPr marL="0" indent="0">
               <a:lnSpc>
                 <a:spcPct val="105000"/>
               </a:lnSpc>
@@ -8277,7 +8431,7 @@
           <a:bodyPr wrap="square" rtlCol="0" anchor="ctr"/>
           <a:lstStyle/>
           <a:p>
-            <a:pPr algn="r" indent="0" marL="0">
+            <a:pPr marL="0" indent="0" algn="r">
               <a:buNone/>
             </a:pPr>
             <a:r>
@@ -8311,6 +8465,7 @@
         <a:solidFill>
           <a:srgbClr val="F5F5F2"/>
         </a:solidFill>
+        <a:effectLst/>
       </p:bgPr>
     </p:bg>
     <p:spTree>
@@ -8348,11 +8503,11 @@
           <a:bodyPr wrap="square" lIns="0" tIns="0" rIns="0" bIns="0" rtlCol="0" anchor="ctr"/>
           <a:lstStyle/>
           <a:p>
-            <a:pPr indent="0" marL="0">
-              <a:buNone/>
-            </a:pPr>
-            <a:r>
-              <a:rPr lang="en-US" sz="1200" b="1" spc="300" kern="0" dirty="0">
+            <a:pPr marL="0" indent="0">
+              <a:buNone/>
+            </a:pPr>
+            <a:r>
+              <a:rPr lang="en-US" sz="1200" b="1" kern="0" spc="300" dirty="0">
                 <a:solidFill>
                   <a:srgbClr val="69A297"/>
                 </a:solidFill>
@@ -8387,7 +8542,7 @@
           <a:bodyPr wrap="square" lIns="0" tIns="0" rIns="0" bIns="0" rtlCol="0" anchor="ctr"/>
           <a:lstStyle/>
           <a:p>
-            <a:pPr indent="0" marL="0">
+            <a:pPr marL="0" indent="0">
               <a:lnSpc>
                 <a:spcPct val="98000"/>
               </a:lnSpc>
@@ -8535,13 +8690,20 @@
           </a:solidFill>
           <a:ln/>
           <a:effectLst>
-            <a:outerShdw sx="100000" sy="100000" kx="0" ky="0" algn="bl" rotWithShape="0" blurRad="101600" dist="38100" dir="5400000">
+            <a:outerShdw blurRad="101600" dist="38100" dir="5400000" algn="bl" rotWithShape="0">
               <a:srgbClr val="9AA8A5">
                 <a:alpha val="28000"/>
               </a:srgbClr>
             </a:outerShdw>
           </a:effectLst>
         </p:spPr>
+        <p:txBody>
+          <a:bodyPr/>
+          <a:lstStyle/>
+          <a:p>
+            <a:endParaRPr lang="es-ES"/>
+          </a:p>
+        </p:txBody>
       </p:sp>
       <p:sp>
         <p:nvSpPr>
@@ -8564,7 +8726,7 @@
           <a:bodyPr wrap="square" lIns="0" tIns="0" rIns="0" bIns="0" rtlCol="0" anchor="ctr"/>
           <a:lstStyle/>
           <a:p>
-            <a:pPr indent="0" marL="0">
+            <a:pPr marL="0" indent="0">
               <a:buNone/>
             </a:pPr>
             <a:r>
@@ -8603,13 +8765,20 @@
           </a:solidFill>
           <a:ln/>
           <a:effectLst>
-            <a:outerShdw sx="100000" sy="100000" kx="0" ky="0" algn="bl" rotWithShape="0" blurRad="101600" dist="38100" dir="5400000">
+            <a:outerShdw blurRad="101600" dist="38100" dir="5400000" algn="bl" rotWithShape="0">
               <a:srgbClr val="9AA8A5">
                 <a:alpha val="28000"/>
               </a:srgbClr>
             </a:outerShdw>
           </a:effectLst>
         </p:spPr>
+        <p:txBody>
+          <a:bodyPr/>
+          <a:lstStyle/>
+          <a:p>
+            <a:endParaRPr lang="es-ES"/>
+          </a:p>
+        </p:txBody>
       </p:sp>
       <p:sp>
         <p:nvSpPr>
@@ -8632,7 +8801,7 @@
           <a:bodyPr wrap="square" lIns="0" tIns="0" rIns="0" bIns="0" rtlCol="0" anchor="ctr"/>
           <a:lstStyle/>
           <a:p>
-            <a:pPr indent="0" marL="0">
+            <a:pPr marL="0" indent="0">
               <a:buNone/>
             </a:pPr>
             <a:r>
@@ -8671,13 +8840,20 @@
           </a:solidFill>
           <a:ln/>
           <a:effectLst>
-            <a:outerShdw sx="100000" sy="100000" kx="0" ky="0" algn="bl" rotWithShape="0" blurRad="101600" dist="38100" dir="5400000">
+            <a:outerShdw blurRad="101600" dist="38100" dir="5400000" algn="bl" rotWithShape="0">
               <a:srgbClr val="9AA8A5">
                 <a:alpha val="28000"/>
               </a:srgbClr>
             </a:outerShdw>
           </a:effectLst>
         </p:spPr>
+        <p:txBody>
+          <a:bodyPr/>
+          <a:lstStyle/>
+          <a:p>
+            <a:endParaRPr lang="es-ES"/>
+          </a:p>
+        </p:txBody>
       </p:sp>
       <p:sp>
         <p:nvSpPr>
@@ -8700,7 +8876,7 @@
           <a:bodyPr wrap="square" lIns="0" tIns="0" rIns="0" bIns="0" rtlCol="0" anchor="ctr"/>
           <a:lstStyle/>
           <a:p>
-            <a:pPr indent="0" marL="0">
+            <a:pPr marL="0" indent="0">
               <a:buNone/>
             </a:pPr>
             <a:r>
@@ -8739,6 +8915,13 @@
           </a:solidFill>
           <a:ln/>
         </p:spPr>
+        <p:txBody>
+          <a:bodyPr/>
+          <a:lstStyle/>
+          <a:p>
+            <a:endParaRPr lang="es-ES"/>
+          </a:p>
+        </p:txBody>
       </p:sp>
       <p:sp>
         <p:nvSpPr>
@@ -8761,7 +8944,7 @@
           <a:bodyPr wrap="square" lIns="0" tIns="0" rIns="0" bIns="0" rtlCol="0" anchor="ctr"/>
           <a:lstStyle/>
           <a:p>
-            <a:pPr algn="ctr" indent="0" marL="0">
+            <a:pPr marL="0" indent="0" algn="ctr">
               <a:buNone/>
             </a:pPr>
             <a:r>
@@ -8800,7 +8983,7 @@
           <a:bodyPr wrap="square" rtlCol="0" anchor="ctr"/>
           <a:lstStyle/>
           <a:p>
-            <a:pPr algn="r" indent="0" marL="0">
+            <a:pPr marL="0" indent="0" algn="r">
               <a:buNone/>
             </a:pPr>
             <a:r>
@@ -8834,6 +9017,7 @@
         <a:solidFill>
           <a:srgbClr val="F5F5F2"/>
         </a:solidFill>
+        <a:effectLst/>
       </p:bgPr>
     </p:bg>
     <p:spTree>
@@ -8871,11 +9055,11 @@
           <a:bodyPr wrap="square" lIns="0" tIns="0" rIns="0" bIns="0" rtlCol="0" anchor="ctr"/>
           <a:lstStyle/>
           <a:p>
-            <a:pPr indent="0" marL="0">
-              <a:buNone/>
-            </a:pPr>
-            <a:r>
-              <a:rPr lang="en-US" sz="1200" b="1" spc="300" kern="0" dirty="0">
+            <a:pPr marL="0" indent="0">
+              <a:buNone/>
+            </a:pPr>
+            <a:r>
+              <a:rPr lang="en-US" sz="1200" b="1" kern="0" spc="300" dirty="0">
                 <a:solidFill>
                   <a:srgbClr val="69A297"/>
                 </a:solidFill>
@@ -8910,14 +9094,14 @@
           <a:bodyPr wrap="square" lIns="0" tIns="0" rIns="0" bIns="0" rtlCol="0" anchor="ctr"/>
           <a:lstStyle/>
           <a:p>
-            <a:pPr indent="0" marL="0">
+            <a:pPr marL="0" indent="0">
               <a:lnSpc>
                 <a:spcPct val="98000"/>
               </a:lnSpc>
               <a:buNone/>
             </a:pPr>
             <a:r>
-              <a:rPr lang="en-US" sz="3000" b="1" dirty="0">
+              <a:rPr lang="en-US" sz="3000" b="1" dirty="0" err="1">
                 <a:solidFill>
                   <a:srgbClr val="2F4A4E"/>
                 </a:solidFill>
@@ -8925,7 +9109,18 @@
                 <a:ea typeface="Cambria" pitchFamily="34" charset="-122"/>
                 <a:cs typeface="Cambria" pitchFamily="34" charset="-120"/>
               </a:rPr>
-              <a:t>Vivetutiempo: del hueco de agenda al evento público</a:t>
+              <a:t>Todoeltiempocuenta</a:t>
+            </a:r>
+            <a:r>
+              <a:rPr lang="en-US" sz="3000" b="1" dirty="0">
+                <a:solidFill>
+                  <a:srgbClr val="2F4A4E"/>
+                </a:solidFill>
+                <a:latin typeface="Cambria" pitchFamily="34" charset="0"/>
+                <a:ea typeface="Cambria" pitchFamily="34" charset="-122"/>
+                <a:cs typeface="Cambria" pitchFamily="34" charset="-120"/>
+              </a:rPr>
+              <a:t>: del hueco de agenda al evento público</a:t>
             </a:r>
             <a:endParaRPr lang="en-US" sz="3000" dirty="0"/>
           </a:p>
@@ -8950,6 +9145,13 @@
           </a:solidFill>
           <a:ln/>
         </p:spPr>
+        <p:txBody>
+          <a:bodyPr/>
+          <a:lstStyle/>
+          <a:p>
+            <a:endParaRPr lang="es-ES"/>
+          </a:p>
+        </p:txBody>
       </p:sp>
       <p:sp>
         <p:nvSpPr>
@@ -8972,7 +9174,7 @@
           <a:bodyPr wrap="square" lIns="0" tIns="0" rIns="0" bIns="0" rtlCol="0" anchor="ctr"/>
           <a:lstStyle/>
           <a:p>
-            <a:pPr algn="ctr" indent="0" marL="0">
+            <a:pPr marL="0" indent="0" algn="ctr">
               <a:buNone/>
             </a:pPr>
             <a:r>
@@ -9011,7 +9213,7 @@
           <a:bodyPr wrap="square" lIns="0" tIns="0" rIns="0" bIns="0" rtlCol="0" anchor="ctr"/>
           <a:lstStyle/>
           <a:p>
-            <a:pPr indent="0" marL="0">
+            <a:pPr marL="0" indent="0">
               <a:buNone/>
             </a:pPr>
             <a:r>
@@ -9048,6 +9250,13 @@
           </a:solidFill>
           <a:ln/>
         </p:spPr>
+        <p:txBody>
+          <a:bodyPr/>
+          <a:lstStyle/>
+          <a:p>
+            <a:endParaRPr lang="es-ES"/>
+          </a:p>
+        </p:txBody>
       </p:sp>
       <p:sp>
         <p:nvSpPr>
@@ -9070,7 +9279,7 @@
           <a:bodyPr wrap="square" lIns="0" tIns="0" rIns="0" bIns="0" rtlCol="0" anchor="ctr"/>
           <a:lstStyle/>
           <a:p>
-            <a:pPr algn="ctr" indent="0" marL="0">
+            <a:pPr marL="0" indent="0" algn="ctr">
               <a:buNone/>
             </a:pPr>
             <a:r>
@@ -9109,7 +9318,7 @@
           <a:bodyPr wrap="square" lIns="0" tIns="0" rIns="0" bIns="0" rtlCol="0" anchor="ctr"/>
           <a:lstStyle/>
           <a:p>
-            <a:pPr indent="0" marL="0">
+            <a:pPr marL="0" indent="0">
               <a:buNone/>
             </a:pPr>
             <a:r>
@@ -9146,6 +9355,13 @@
           </a:solidFill>
           <a:ln/>
         </p:spPr>
+        <p:txBody>
+          <a:bodyPr/>
+          <a:lstStyle/>
+          <a:p>
+            <a:endParaRPr lang="es-ES"/>
+          </a:p>
+        </p:txBody>
       </p:sp>
       <p:sp>
         <p:nvSpPr>
@@ -9168,7 +9384,7 @@
           <a:bodyPr wrap="square" lIns="0" tIns="0" rIns="0" bIns="0" rtlCol="0" anchor="ctr"/>
           <a:lstStyle/>
           <a:p>
-            <a:pPr algn="ctr" indent="0" marL="0">
+            <a:pPr marL="0" indent="0" algn="ctr">
               <a:buNone/>
             </a:pPr>
             <a:r>
@@ -9207,7 +9423,7 @@
           <a:bodyPr wrap="square" lIns="0" tIns="0" rIns="0" bIns="0" rtlCol="0" anchor="ctr"/>
           <a:lstStyle/>
           <a:p>
-            <a:pPr indent="0" marL="0">
+            <a:pPr marL="0" indent="0">
               <a:buNone/>
             </a:pPr>
             <a:r>
@@ -9244,6 +9460,13 @@
           </a:solidFill>
           <a:ln/>
         </p:spPr>
+        <p:txBody>
+          <a:bodyPr/>
+          <a:lstStyle/>
+          <a:p>
+            <a:endParaRPr lang="es-ES"/>
+          </a:p>
+        </p:txBody>
       </p:sp>
       <p:sp>
         <p:nvSpPr>
@@ -9266,7 +9489,7 @@
           <a:bodyPr wrap="square" lIns="0" tIns="0" rIns="0" bIns="0" rtlCol="0" anchor="ctr"/>
           <a:lstStyle/>
           <a:p>
-            <a:pPr algn="ctr" indent="0" marL="0">
+            <a:pPr marL="0" indent="0" algn="ctr">
               <a:buNone/>
             </a:pPr>
             <a:r>
@@ -9305,7 +9528,7 @@
           <a:bodyPr wrap="square" lIns="0" tIns="0" rIns="0" bIns="0" rtlCol="0" anchor="ctr"/>
           <a:lstStyle/>
           <a:p>
-            <a:pPr indent="0" marL="0">
+            <a:pPr marL="0" indent="0">
               <a:buNone/>
             </a:pPr>
             <a:r>
@@ -9342,6 +9565,13 @@
           </a:solidFill>
           <a:ln/>
         </p:spPr>
+        <p:txBody>
+          <a:bodyPr/>
+          <a:lstStyle/>
+          <a:p>
+            <a:endParaRPr lang="es-ES"/>
+          </a:p>
+        </p:txBody>
       </p:sp>
       <p:sp>
         <p:nvSpPr>
@@ -9364,7 +9594,7 @@
           <a:bodyPr wrap="square" lIns="0" tIns="0" rIns="0" bIns="0" rtlCol="0" anchor="ctr"/>
           <a:lstStyle/>
           <a:p>
-            <a:pPr algn="ctr" indent="0" marL="0">
+            <a:pPr marL="0" indent="0" algn="ctr">
               <a:buNone/>
             </a:pPr>
             <a:r>
@@ -9403,7 +9633,7 @@
           <a:bodyPr wrap="square" lIns="0" tIns="0" rIns="0" bIns="0" rtlCol="0" anchor="ctr"/>
           <a:lstStyle/>
           <a:p>
-            <a:pPr indent="0" marL="0">
+            <a:pPr marL="0" indent="0">
               <a:buNone/>
             </a:pPr>
             <a:r>
@@ -9442,6 +9672,13 @@
           </a:solidFill>
           <a:ln/>
         </p:spPr>
+        <p:txBody>
+          <a:bodyPr/>
+          <a:lstStyle/>
+          <a:p>
+            <a:endParaRPr lang="es-ES"/>
+          </a:p>
+        </p:txBody>
       </p:sp>
       <p:sp>
         <p:nvSpPr>
@@ -9464,7 +9701,7 @@
           <a:bodyPr wrap="square" lIns="0" tIns="0" rIns="0" bIns="0" rtlCol="0" anchor="ctr"/>
           <a:lstStyle/>
           <a:p>
-            <a:pPr indent="0" marL="0">
+            <a:pPr marL="0" indent="0">
               <a:buNone/>
             </a:pPr>
             <a:r>
@@ -9503,7 +9740,7 @@
           <a:bodyPr wrap="square" lIns="0" tIns="0" rIns="0" bIns="0" rtlCol="0" anchor="ctr"/>
           <a:lstStyle/>
           <a:p>
-            <a:pPr indent="0" marL="0">
+            <a:pPr marL="0" indent="0">
               <a:lnSpc>
                 <a:spcPct val="112000"/>
               </a:lnSpc>
@@ -9545,7 +9782,7 @@
           <a:bodyPr wrap="square" rtlCol="0" anchor="ctr"/>
           <a:lstStyle/>
           <a:p>
-            <a:pPr algn="r" indent="0" marL="0">
+            <a:pPr marL="0" indent="0" algn="r">
               <a:buNone/>
             </a:pPr>
             <a:r>
@@ -9579,6 +9816,7 @@
         <a:solidFill>
           <a:srgbClr val="F5F5F2"/>
         </a:solidFill>
+        <a:effectLst/>
       </p:bgPr>
     </p:bg>
     <p:spTree>
@@ -9616,11 +9854,11 @@
           <a:bodyPr wrap="square" lIns="0" tIns="0" rIns="0" bIns="0" rtlCol="0" anchor="ctr"/>
           <a:lstStyle/>
           <a:p>
-            <a:pPr indent="0" marL="0">
-              <a:buNone/>
-            </a:pPr>
-            <a:r>
-              <a:rPr lang="en-US" sz="1200" b="1" spc="300" kern="0" dirty="0">
+            <a:pPr marL="0" indent="0">
+              <a:buNone/>
+            </a:pPr>
+            <a:r>
+              <a:rPr lang="en-US" sz="1200" b="1" kern="0" spc="300" dirty="0">
                 <a:solidFill>
                   <a:srgbClr val="69A297"/>
                 </a:solidFill>
@@ -9655,7 +9893,7 @@
           <a:bodyPr wrap="square" lIns="0" tIns="0" rIns="0" bIns="0" rtlCol="0" anchor="ctr"/>
           <a:lstStyle/>
           <a:p>
-            <a:pPr indent="0" marL="0">
+            <a:pPr marL="0" indent="0">
               <a:lnSpc>
                 <a:spcPct val="98000"/>
               </a:lnSpc>
@@ -9697,13 +9935,20 @@
           </a:solidFill>
           <a:ln/>
           <a:effectLst>
-            <a:outerShdw sx="100000" sy="100000" kx="0" ky="0" algn="bl" rotWithShape="0" blurRad="101600" dist="38100" dir="5400000">
+            <a:outerShdw blurRad="101600" dist="38100" dir="5400000" algn="bl" rotWithShape="0">
               <a:srgbClr val="9AA8A5">
                 <a:alpha val="28000"/>
               </a:srgbClr>
             </a:outerShdw>
           </a:effectLst>
         </p:spPr>
+        <p:txBody>
+          <a:bodyPr/>
+          <a:lstStyle/>
+          <a:p>
+            <a:endParaRPr lang="es-ES"/>
+          </a:p>
+        </p:txBody>
       </p:sp>
       <p:sp>
         <p:nvSpPr>
@@ -9726,6 +9971,13 @@
           </a:solidFill>
           <a:ln/>
         </p:spPr>
+        <p:txBody>
+          <a:bodyPr/>
+          <a:lstStyle/>
+          <a:p>
+            <a:endParaRPr lang="es-ES"/>
+          </a:p>
+        </p:txBody>
       </p:sp>
       <p:sp>
         <p:nvSpPr>
@@ -9748,7 +10000,7 @@
           <a:bodyPr wrap="square" lIns="0" tIns="0" rIns="0" bIns="0" rtlCol="0" anchor="t"/>
           <a:lstStyle/>
           <a:p>
-            <a:pPr indent="0" marL="0">
+            <a:pPr marL="0" indent="0">
               <a:buNone/>
             </a:pPr>
             <a:r>
@@ -9787,7 +10039,7 @@
           <a:bodyPr wrap="square" lIns="0" tIns="0" rIns="0" bIns="0" rtlCol="0" anchor="t"/>
           <a:lstStyle/>
           <a:p>
-            <a:pPr indent="0" marL="0">
+            <a:pPr marL="0" indent="0">
               <a:lnSpc>
                 <a:spcPct val="105000"/>
               </a:lnSpc>
@@ -9829,7 +10081,7 @@
           <a:bodyPr wrap="square" lIns="0" tIns="0" rIns="0" bIns="0" rtlCol="0" anchor="t"/>
           <a:lstStyle/>
           <a:p>
-            <a:pPr indent="0" marL="0">
+            <a:pPr marL="0" indent="0">
               <a:lnSpc>
                 <a:spcPct val="105000"/>
               </a:lnSpc>
@@ -9871,13 +10123,20 @@
           </a:solidFill>
           <a:ln/>
           <a:effectLst>
-            <a:outerShdw sx="100000" sy="100000" kx="0" ky="0" algn="bl" rotWithShape="0" blurRad="101600" dist="38100" dir="5400000">
+            <a:outerShdw blurRad="101600" dist="38100" dir="5400000" algn="bl" rotWithShape="0">
               <a:srgbClr val="9AA8A5">
                 <a:alpha val="28000"/>
               </a:srgbClr>
             </a:outerShdw>
           </a:effectLst>
         </p:spPr>
+        <p:txBody>
+          <a:bodyPr/>
+          <a:lstStyle/>
+          <a:p>
+            <a:endParaRPr lang="es-ES"/>
+          </a:p>
+        </p:txBody>
       </p:sp>
       <p:sp>
         <p:nvSpPr>
@@ -9900,6 +10159,13 @@
           </a:solidFill>
           <a:ln/>
         </p:spPr>
+        <p:txBody>
+          <a:bodyPr/>
+          <a:lstStyle/>
+          <a:p>
+            <a:endParaRPr lang="es-ES"/>
+          </a:p>
+        </p:txBody>
       </p:sp>
       <p:sp>
         <p:nvSpPr>
@@ -9922,7 +10188,7 @@
           <a:bodyPr wrap="square" lIns="0" tIns="0" rIns="0" bIns="0" rtlCol="0" anchor="t"/>
           <a:lstStyle/>
           <a:p>
-            <a:pPr indent="0" marL="0">
+            <a:pPr marL="0" indent="0">
               <a:buNone/>
             </a:pPr>
             <a:r>
@@ -9961,7 +10227,7 @@
           <a:bodyPr wrap="square" lIns="0" tIns="0" rIns="0" bIns="0" rtlCol="0" anchor="t"/>
           <a:lstStyle/>
           <a:p>
-            <a:pPr indent="0" marL="0">
+            <a:pPr marL="0" indent="0">
               <a:lnSpc>
                 <a:spcPct val="105000"/>
               </a:lnSpc>
@@ -10003,7 +10269,7 @@
           <a:bodyPr wrap="square" lIns="0" tIns="0" rIns="0" bIns="0" rtlCol="0" anchor="t"/>
           <a:lstStyle/>
           <a:p>
-            <a:pPr indent="0" marL="0">
+            <a:pPr marL="0" indent="0">
               <a:lnSpc>
                 <a:spcPct val="105000"/>
               </a:lnSpc>
@@ -10045,13 +10311,20 @@
           </a:solidFill>
           <a:ln/>
           <a:effectLst>
-            <a:outerShdw sx="100000" sy="100000" kx="0" ky="0" algn="bl" rotWithShape="0" blurRad="101600" dist="38100" dir="5400000">
+            <a:outerShdw blurRad="101600" dist="38100" dir="5400000" algn="bl" rotWithShape="0">
               <a:srgbClr val="9AA8A5">
                 <a:alpha val="28000"/>
               </a:srgbClr>
             </a:outerShdw>
           </a:effectLst>
         </p:spPr>
+        <p:txBody>
+          <a:bodyPr/>
+          <a:lstStyle/>
+          <a:p>
+            <a:endParaRPr lang="es-ES"/>
+          </a:p>
+        </p:txBody>
       </p:sp>
       <p:sp>
         <p:nvSpPr>
@@ -10074,6 +10347,13 @@
           </a:solidFill>
           <a:ln/>
         </p:spPr>
+        <p:txBody>
+          <a:bodyPr/>
+          <a:lstStyle/>
+          <a:p>
+            <a:endParaRPr lang="es-ES"/>
+          </a:p>
+        </p:txBody>
       </p:sp>
       <p:sp>
         <p:nvSpPr>
@@ -10096,7 +10376,7 @@
           <a:bodyPr wrap="square" lIns="0" tIns="0" rIns="0" bIns="0" rtlCol="0" anchor="t"/>
           <a:lstStyle/>
           <a:p>
-            <a:pPr indent="0" marL="0">
+            <a:pPr marL="0" indent="0">
               <a:buNone/>
             </a:pPr>
             <a:r>
@@ -10135,7 +10415,7 @@
           <a:bodyPr wrap="square" lIns="0" tIns="0" rIns="0" bIns="0" rtlCol="0" anchor="t"/>
           <a:lstStyle/>
           <a:p>
-            <a:pPr indent="0" marL="0">
+            <a:pPr marL="0" indent="0">
               <a:lnSpc>
                 <a:spcPct val="105000"/>
               </a:lnSpc>
@@ -10177,7 +10457,7 @@
           <a:bodyPr wrap="square" lIns="0" tIns="0" rIns="0" bIns="0" rtlCol="0" anchor="t"/>
           <a:lstStyle/>
           <a:p>
-            <a:pPr indent="0" marL="0">
+            <a:pPr marL="0" indent="0">
               <a:lnSpc>
                 <a:spcPct val="105000"/>
               </a:lnSpc>
@@ -10219,7 +10499,7 @@
           <a:bodyPr wrap="square" lIns="0" tIns="0" rIns="0" bIns="0" rtlCol="0" anchor="ctr"/>
           <a:lstStyle/>
           <a:p>
-            <a:pPr indent="0" marL="0">
+            <a:pPr marL="0" indent="0">
               <a:buNone/>
             </a:pPr>
             <a:r>
@@ -10258,7 +10538,7 @@
           <a:bodyPr wrap="square" rtlCol="0" anchor="ctr"/>
           <a:lstStyle/>
           <a:p>
-            <a:pPr algn="r" indent="0" marL="0">
+            <a:pPr marL="0" indent="0" algn="r">
               <a:buNone/>
             </a:pPr>
             <a:r>
@@ -10292,6 +10572,7 @@
         <a:solidFill>
           <a:srgbClr val="F5F5F2"/>
         </a:solidFill>
+        <a:effectLst/>
       </p:bgPr>
     </p:bg>
     <p:spTree>
@@ -10329,11 +10610,11 @@
           <a:bodyPr wrap="square" lIns="0" tIns="0" rIns="0" bIns="0" rtlCol="0" anchor="ctr"/>
           <a:lstStyle/>
           <a:p>
-            <a:pPr indent="0" marL="0">
-              <a:buNone/>
-            </a:pPr>
-            <a:r>
-              <a:rPr lang="en-US" sz="1200" b="1" spc="300" kern="0" dirty="0">
+            <a:pPr marL="0" indent="0">
+              <a:buNone/>
+            </a:pPr>
+            <a:r>
+              <a:rPr lang="en-US" sz="1200" b="1" kern="0" spc="300" dirty="0">
                 <a:solidFill>
                   <a:srgbClr val="69A297"/>
                 </a:solidFill>
@@ -10368,7 +10649,7 @@
           <a:bodyPr wrap="square" lIns="0" tIns="0" rIns="0" bIns="0" rtlCol="0" anchor="ctr"/>
           <a:lstStyle/>
           <a:p>
-            <a:pPr indent="0" marL="0">
+            <a:pPr marL="0" indent="0">
               <a:lnSpc>
                 <a:spcPct val="98000"/>
               </a:lnSpc>
@@ -10410,13 +10691,20 @@
           </a:solidFill>
           <a:ln/>
           <a:effectLst>
-            <a:outerShdw sx="100000" sy="100000" kx="0" ky="0" algn="bl" rotWithShape="0" blurRad="101600" dist="38100" dir="5400000">
+            <a:outerShdw blurRad="101600" dist="38100" dir="5400000" algn="bl" rotWithShape="0">
               <a:srgbClr val="9AA8A5">
                 <a:alpha val="28000"/>
               </a:srgbClr>
             </a:outerShdw>
           </a:effectLst>
         </p:spPr>
+        <p:txBody>
+          <a:bodyPr/>
+          <a:lstStyle/>
+          <a:p>
+            <a:endParaRPr lang="es-ES"/>
+          </a:p>
+        </p:txBody>
       </p:sp>
       <p:sp>
         <p:nvSpPr>
@@ -10439,7 +10727,7 @@
           <a:bodyPr wrap="square" lIns="0" tIns="0" rIns="0" bIns="0" rtlCol="0" anchor="ctr"/>
           <a:lstStyle/>
           <a:p>
-            <a:pPr indent="0" marL="0">
+            <a:pPr marL="0" indent="0">
               <a:buNone/>
             </a:pPr>
             <a:r>
@@ -10478,7 +10766,7 @@
           <a:bodyPr wrap="square" lIns="0" tIns="0" rIns="0" bIns="0" rtlCol="0" anchor="ctr"/>
           <a:lstStyle/>
           <a:p>
-            <a:pPr indent="0" marL="0">
+            <a:pPr marL="0" indent="0">
               <a:lnSpc>
                 <a:spcPct val="105000"/>
               </a:lnSpc>
@@ -10520,13 +10808,20 @@
           </a:solidFill>
           <a:ln/>
           <a:effectLst>
-            <a:outerShdw sx="100000" sy="100000" kx="0" ky="0" algn="bl" rotWithShape="0" blurRad="101600" dist="38100" dir="5400000">
+            <a:outerShdw blurRad="101600" dist="38100" dir="5400000" algn="bl" rotWithShape="0">
               <a:srgbClr val="9AA8A5">
                 <a:alpha val="28000"/>
               </a:srgbClr>
             </a:outerShdw>
           </a:effectLst>
         </p:spPr>
+        <p:txBody>
+          <a:bodyPr/>
+          <a:lstStyle/>
+          <a:p>
+            <a:endParaRPr lang="es-ES"/>
+          </a:p>
+        </p:txBody>
       </p:sp>
       <p:sp>
         <p:nvSpPr>
@@ -10549,7 +10844,7 @@
           <a:bodyPr wrap="square" lIns="0" tIns="0" rIns="0" bIns="0" rtlCol="0" anchor="ctr"/>
           <a:lstStyle/>
           <a:p>
-            <a:pPr indent="0" marL="0">
+            <a:pPr marL="0" indent="0">
               <a:buNone/>
             </a:pPr>
             <a:r>
@@ -10588,7 +10883,7 @@
           <a:bodyPr wrap="square" lIns="0" tIns="0" rIns="0" bIns="0" rtlCol="0" anchor="ctr"/>
           <a:lstStyle/>
           <a:p>
-            <a:pPr indent="0" marL="0">
+            <a:pPr marL="0" indent="0">
               <a:lnSpc>
                 <a:spcPct val="105000"/>
               </a:lnSpc>
@@ -10630,13 +10925,20 @@
           </a:solidFill>
           <a:ln/>
           <a:effectLst>
-            <a:outerShdw sx="100000" sy="100000" kx="0" ky="0" algn="bl" rotWithShape="0" blurRad="101600" dist="38100" dir="5400000">
+            <a:outerShdw blurRad="101600" dist="38100" dir="5400000" algn="bl" rotWithShape="0">
               <a:srgbClr val="9AA8A5">
                 <a:alpha val="28000"/>
               </a:srgbClr>
             </a:outerShdw>
           </a:effectLst>
         </p:spPr>
+        <p:txBody>
+          <a:bodyPr/>
+          <a:lstStyle/>
+          <a:p>
+            <a:endParaRPr lang="es-ES"/>
+          </a:p>
+        </p:txBody>
       </p:sp>
       <p:sp>
         <p:nvSpPr>
@@ -10659,7 +10961,7 @@
           <a:bodyPr wrap="square" lIns="0" tIns="0" rIns="0" bIns="0" rtlCol="0" anchor="ctr"/>
           <a:lstStyle/>
           <a:p>
-            <a:pPr indent="0" marL="0">
+            <a:pPr marL="0" indent="0">
               <a:buNone/>
             </a:pPr>
             <a:r>
@@ -10698,7 +11000,7 @@
           <a:bodyPr wrap="square" lIns="0" tIns="0" rIns="0" bIns="0" rtlCol="0" anchor="ctr"/>
           <a:lstStyle/>
           <a:p>
-            <a:pPr indent="0" marL="0">
+            <a:pPr marL="0" indent="0">
               <a:lnSpc>
                 <a:spcPct val="105000"/>
               </a:lnSpc>
@@ -10740,13 +11042,20 @@
           </a:solidFill>
           <a:ln/>
           <a:effectLst>
-            <a:outerShdw sx="100000" sy="100000" kx="0" ky="0" algn="bl" rotWithShape="0" blurRad="101600" dist="38100" dir="5400000">
+            <a:outerShdw blurRad="101600" dist="38100" dir="5400000" algn="bl" rotWithShape="0">
               <a:srgbClr val="9AA8A5">
                 <a:alpha val="28000"/>
               </a:srgbClr>
             </a:outerShdw>
           </a:effectLst>
         </p:spPr>
+        <p:txBody>
+          <a:bodyPr/>
+          <a:lstStyle/>
+          <a:p>
+            <a:endParaRPr lang="es-ES"/>
+          </a:p>
+        </p:txBody>
       </p:sp>
       <p:sp>
         <p:nvSpPr>
@@ -10769,7 +11078,7 @@
           <a:bodyPr wrap="square" lIns="0" tIns="0" rIns="0" bIns="0" rtlCol="0" anchor="ctr"/>
           <a:lstStyle/>
           <a:p>
-            <a:pPr indent="0" marL="0">
+            <a:pPr marL="0" indent="0">
               <a:buNone/>
             </a:pPr>
             <a:r>
@@ -10808,7 +11117,7 @@
           <a:bodyPr wrap="square" lIns="0" tIns="0" rIns="0" bIns="0" rtlCol="0" anchor="ctr"/>
           <a:lstStyle/>
           <a:p>
-            <a:pPr indent="0" marL="0">
+            <a:pPr marL="0" indent="0">
               <a:lnSpc>
                 <a:spcPct val="105000"/>
               </a:lnSpc>
@@ -10850,13 +11159,20 @@
           </a:solidFill>
           <a:ln/>
           <a:effectLst>
-            <a:outerShdw sx="100000" sy="100000" kx="0" ky="0" algn="bl" rotWithShape="0" blurRad="101600" dist="38100" dir="5400000">
+            <a:outerShdw blurRad="101600" dist="38100" dir="5400000" algn="bl" rotWithShape="0">
               <a:srgbClr val="9AA8A5">
                 <a:alpha val="28000"/>
               </a:srgbClr>
             </a:outerShdw>
           </a:effectLst>
         </p:spPr>
+        <p:txBody>
+          <a:bodyPr/>
+          <a:lstStyle/>
+          <a:p>
+            <a:endParaRPr lang="es-ES"/>
+          </a:p>
+        </p:txBody>
       </p:sp>
       <p:sp>
         <p:nvSpPr>
@@ -10879,7 +11195,7 @@
           <a:bodyPr wrap="square" lIns="0" tIns="0" rIns="0" bIns="0" rtlCol="0" anchor="ctr"/>
           <a:lstStyle/>
           <a:p>
-            <a:pPr indent="0" marL="0">
+            <a:pPr marL="0" indent="0">
               <a:buNone/>
             </a:pPr>
             <a:r>
@@ -10918,7 +11234,7 @@
           <a:bodyPr wrap="square" lIns="0" tIns="0" rIns="0" bIns="0" rtlCol="0" anchor="ctr"/>
           <a:lstStyle/>
           <a:p>
-            <a:pPr indent="0" marL="0">
+            <a:pPr marL="0" indent="0">
               <a:lnSpc>
                 <a:spcPct val="105000"/>
               </a:lnSpc>
@@ -10960,13 +11276,20 @@
           </a:solidFill>
           <a:ln/>
           <a:effectLst>
-            <a:outerShdw sx="100000" sy="100000" kx="0" ky="0" algn="bl" rotWithShape="0" blurRad="101600" dist="38100" dir="5400000">
+            <a:outerShdw blurRad="101600" dist="38100" dir="5400000" algn="bl" rotWithShape="0">
               <a:srgbClr val="9AA8A5">
                 <a:alpha val="28000"/>
               </a:srgbClr>
             </a:outerShdw>
           </a:effectLst>
         </p:spPr>
+        <p:txBody>
+          <a:bodyPr/>
+          <a:lstStyle/>
+          <a:p>
+            <a:endParaRPr lang="es-ES"/>
+          </a:p>
+        </p:txBody>
       </p:sp>
       <p:sp>
         <p:nvSpPr>
@@ -10989,7 +11312,7 @@
           <a:bodyPr wrap="square" lIns="0" tIns="0" rIns="0" bIns="0" rtlCol="0" anchor="ctr"/>
           <a:lstStyle/>
           <a:p>
-            <a:pPr indent="0" marL="0">
+            <a:pPr marL="0" indent="0">
               <a:buNone/>
             </a:pPr>
             <a:r>
@@ -11028,7 +11351,7 @@
           <a:bodyPr wrap="square" lIns="0" tIns="0" rIns="0" bIns="0" rtlCol="0" anchor="ctr"/>
           <a:lstStyle/>
           <a:p>
-            <a:pPr indent="0" marL="0">
+            <a:pPr marL="0" indent="0">
               <a:lnSpc>
                 <a:spcPct val="105000"/>
               </a:lnSpc>
@@ -11070,7 +11393,7 @@
           <a:bodyPr wrap="square" rtlCol="0" anchor="ctr"/>
           <a:lstStyle/>
           <a:p>
-            <a:pPr algn="r" indent="0" marL="0">
+            <a:pPr marL="0" indent="0" algn="r">
               <a:buNone/>
             </a:pPr>
             <a:r>
@@ -11104,6 +11427,7 @@
         <a:solidFill>
           <a:srgbClr val="F5F5F2"/>
         </a:solidFill>
+        <a:effectLst/>
       </p:bgPr>
     </p:bg>
     <p:spTree>
@@ -11141,11 +11465,11 @@
           <a:bodyPr wrap="square" lIns="0" tIns="0" rIns="0" bIns="0" rtlCol="0" anchor="ctr"/>
           <a:lstStyle/>
           <a:p>
-            <a:pPr indent="0" marL="0">
-              <a:buNone/>
-            </a:pPr>
-            <a:r>
-              <a:rPr lang="en-US" sz="1200" b="1" spc="300" kern="0" dirty="0">
+            <a:pPr marL="0" indent="0">
+              <a:buNone/>
+            </a:pPr>
+            <a:r>
+              <a:rPr lang="en-US" sz="1200" b="1" kern="0" spc="300" dirty="0">
                 <a:solidFill>
                   <a:srgbClr val="69A297"/>
                 </a:solidFill>
@@ -11180,7 +11504,7 @@
           <a:bodyPr wrap="square" lIns="0" tIns="0" rIns="0" bIns="0" rtlCol="0" anchor="ctr"/>
           <a:lstStyle/>
           <a:p>
-            <a:pPr indent="0" marL="0">
+            <a:pPr marL="0" indent="0">
               <a:lnSpc>
                 <a:spcPct val="98000"/>
               </a:lnSpc>
@@ -11222,13 +11546,20 @@
           </a:solidFill>
           <a:ln/>
           <a:effectLst>
-            <a:outerShdw sx="100000" sy="100000" kx="0" ky="0" algn="bl" rotWithShape="0" blurRad="101600" dist="38100" dir="5400000">
+            <a:outerShdw blurRad="101600" dist="38100" dir="5400000" algn="bl" rotWithShape="0">
               <a:srgbClr val="9AA8A5">
                 <a:alpha val="28000"/>
               </a:srgbClr>
             </a:outerShdw>
           </a:effectLst>
         </p:spPr>
+        <p:txBody>
+          <a:bodyPr/>
+          <a:lstStyle/>
+          <a:p>
+            <a:endParaRPr lang="es-ES"/>
+          </a:p>
+        </p:txBody>
       </p:sp>
       <p:sp>
         <p:nvSpPr>
@@ -11251,7 +11582,7 @@
           <a:bodyPr wrap="square" lIns="0" tIns="0" rIns="0" bIns="0" rtlCol="0" anchor="ctr"/>
           <a:lstStyle/>
           <a:p>
-            <a:pPr indent="0" marL="0">
+            <a:pPr marL="0" indent="0">
               <a:buNone/>
             </a:pPr>
             <a:r>
@@ -11290,7 +11621,7 @@
           <a:bodyPr wrap="square" lIns="0" tIns="0" rIns="0" bIns="0" rtlCol="0" anchor="ctr"/>
           <a:lstStyle/>
           <a:p>
-            <a:pPr indent="0" marL="0">
+            <a:pPr marL="0" indent="0">
               <a:lnSpc>
                 <a:spcPct val="102000"/>
               </a:lnSpc>
@@ -11332,13 +11663,20 @@
           </a:solidFill>
           <a:ln/>
           <a:effectLst>
-            <a:outerShdw sx="100000" sy="100000" kx="0" ky="0" algn="bl" rotWithShape="0" blurRad="101600" dist="38100" dir="5400000">
+            <a:outerShdw blurRad="101600" dist="38100" dir="5400000" algn="bl" rotWithShape="0">
               <a:srgbClr val="9AA8A5">
                 <a:alpha val="28000"/>
               </a:srgbClr>
             </a:outerShdw>
           </a:effectLst>
         </p:spPr>
+        <p:txBody>
+          <a:bodyPr/>
+          <a:lstStyle/>
+          <a:p>
+            <a:endParaRPr lang="es-ES"/>
+          </a:p>
+        </p:txBody>
       </p:sp>
       <p:sp>
         <p:nvSpPr>
@@ -11361,7 +11699,7 @@
           <a:bodyPr wrap="square" lIns="0" tIns="0" rIns="0" bIns="0" rtlCol="0" anchor="ctr"/>
           <a:lstStyle/>
           <a:p>
-            <a:pPr indent="0" marL="0">
+            <a:pPr marL="0" indent="0">
               <a:buNone/>
             </a:pPr>
             <a:r>
@@ -11400,7 +11738,7 @@
           <a:bodyPr wrap="square" lIns="0" tIns="0" rIns="0" bIns="0" rtlCol="0" anchor="ctr"/>
           <a:lstStyle/>
           <a:p>
-            <a:pPr indent="0" marL="0">
+            <a:pPr marL="0" indent="0">
               <a:lnSpc>
                 <a:spcPct val="102000"/>
               </a:lnSpc>
@@ -11442,13 +11780,20 @@
           </a:solidFill>
           <a:ln/>
           <a:effectLst>
-            <a:outerShdw sx="100000" sy="100000" kx="0" ky="0" algn="bl" rotWithShape="0" blurRad="101600" dist="38100" dir="5400000">
+            <a:outerShdw blurRad="101600" dist="38100" dir="5400000" algn="bl" rotWithShape="0">
               <a:srgbClr val="9AA8A5">
                 <a:alpha val="28000"/>
               </a:srgbClr>
             </a:outerShdw>
           </a:effectLst>
         </p:spPr>
+        <p:txBody>
+          <a:bodyPr/>
+          <a:lstStyle/>
+          <a:p>
+            <a:endParaRPr lang="es-ES"/>
+          </a:p>
+        </p:txBody>
       </p:sp>
       <p:sp>
         <p:nvSpPr>
@@ -11471,7 +11816,7 @@
           <a:bodyPr wrap="square" lIns="0" tIns="0" rIns="0" bIns="0" rtlCol="0" anchor="ctr"/>
           <a:lstStyle/>
           <a:p>
-            <a:pPr indent="0" marL="0">
+            <a:pPr marL="0" indent="0">
               <a:buNone/>
             </a:pPr>
             <a:r>
@@ -11510,7 +11855,7 @@
           <a:bodyPr wrap="square" lIns="0" tIns="0" rIns="0" bIns="0" rtlCol="0" anchor="ctr"/>
           <a:lstStyle/>
           <a:p>
-            <a:pPr indent="0" marL="0">
+            <a:pPr marL="0" indent="0">
               <a:lnSpc>
                 <a:spcPct val="102000"/>
               </a:lnSpc>
@@ -11552,13 +11897,20 @@
           </a:solidFill>
           <a:ln/>
           <a:effectLst>
-            <a:outerShdw sx="100000" sy="100000" kx="0" ky="0" algn="bl" rotWithShape="0" blurRad="101600" dist="38100" dir="5400000">
+            <a:outerShdw blurRad="101600" dist="38100" dir="5400000" algn="bl" rotWithShape="0">
               <a:srgbClr val="9AA8A5">
                 <a:alpha val="28000"/>
               </a:srgbClr>
             </a:outerShdw>
           </a:effectLst>
         </p:spPr>
+        <p:txBody>
+          <a:bodyPr/>
+          <a:lstStyle/>
+          <a:p>
+            <a:endParaRPr lang="es-ES"/>
+          </a:p>
+        </p:txBody>
       </p:sp>
       <p:sp>
         <p:nvSpPr>
@@ -11581,7 +11933,7 @@
           <a:bodyPr wrap="square" lIns="0" tIns="0" rIns="0" bIns="0" rtlCol="0" anchor="ctr"/>
           <a:lstStyle/>
           <a:p>
-            <a:pPr indent="0" marL="0">
+            <a:pPr marL="0" indent="0">
               <a:buNone/>
             </a:pPr>
             <a:r>
@@ -11620,7 +11972,7 @@
           <a:bodyPr wrap="square" lIns="0" tIns="0" rIns="0" bIns="0" rtlCol="0" anchor="ctr"/>
           <a:lstStyle/>
           <a:p>
-            <a:pPr indent="0" marL="0">
+            <a:pPr marL="0" indent="0">
               <a:lnSpc>
                 <a:spcPct val="102000"/>
               </a:lnSpc>
@@ -11662,6 +12014,13 @@
           </a:solidFill>
           <a:ln/>
         </p:spPr>
+        <p:txBody>
+          <a:bodyPr/>
+          <a:lstStyle/>
+          <a:p>
+            <a:endParaRPr lang="es-ES"/>
+          </a:p>
+        </p:txBody>
       </p:sp>
       <p:sp>
         <p:nvSpPr>
@@ -11684,7 +12043,7 @@
           <a:bodyPr wrap="square" lIns="0" tIns="0" rIns="0" bIns="0" rtlCol="0" anchor="ctr"/>
           <a:lstStyle/>
           <a:p>
-            <a:pPr indent="0" marL="0">
+            <a:pPr marL="0" indent="0">
               <a:buNone/>
             </a:pPr>
             <a:r>
@@ -11723,7 +12082,7 @@
           <a:bodyPr wrap="square" lIns="0" tIns="0" rIns="0" bIns="0" rtlCol="0" anchor="t"/>
           <a:lstStyle/>
           <a:p>
-            <a:pPr indent="0" marL="0">
+            <a:pPr marL="0" indent="0">
               <a:spcAft>
                 <a:spcPts val="200"/>
               </a:spcAft>
@@ -11743,7 +12102,7 @@
             <a:endParaRPr lang="en-US" sz="1300" dirty="0"/>
           </a:p>
           <a:p>
-            <a:pPr indent="0" marL="0">
+            <a:pPr marL="0" indent="0">
               <a:spcAft>
                 <a:spcPts val="1200"/>
               </a:spcAft>
@@ -11763,7 +12122,7 @@
             <a:endParaRPr lang="en-US" sz="1300" dirty="0"/>
           </a:p>
           <a:p>
-            <a:pPr indent="0" marL="0">
+            <a:pPr marL="0" indent="0">
               <a:spcAft>
                 <a:spcPts val="200"/>
               </a:spcAft>
@@ -11783,7 +12142,7 @@
             <a:endParaRPr lang="en-US" sz="1300" dirty="0"/>
           </a:p>
           <a:p>
-            <a:pPr indent="0" marL="0">
+            <a:pPr marL="0" indent="0">
               <a:spcAft>
                 <a:spcPts val="1200"/>
               </a:spcAft>
@@ -11803,7 +12162,7 @@
             <a:endParaRPr lang="en-US" sz="1300" dirty="0"/>
           </a:p>
           <a:p>
-            <a:pPr indent="0" marL="0">
+            <a:pPr marL="0" indent="0">
               <a:buNone/>
             </a:pPr>
             <a:r>
@@ -11842,7 +12201,7 @@
           <a:bodyPr wrap="square" rtlCol="0" anchor="ctr"/>
           <a:lstStyle/>
           <a:p>
-            <a:pPr algn="r" indent="0" marL="0">
+            <a:pPr marL="0" indent="0" algn="r">
               <a:buNone/>
             </a:pPr>
             <a:r>
@@ -11876,6 +12235,7 @@
         <a:solidFill>
           <a:srgbClr val="F5F5F2"/>
         </a:solidFill>
+        <a:effectLst/>
       </p:bgPr>
     </p:bg>
     <p:spTree>
@@ -11913,11 +12273,11 @@
           <a:bodyPr wrap="square" lIns="0" tIns="0" rIns="0" bIns="0" rtlCol="0" anchor="ctr"/>
           <a:lstStyle/>
           <a:p>
-            <a:pPr indent="0" marL="0">
-              <a:buNone/>
-            </a:pPr>
-            <a:r>
-              <a:rPr lang="en-US" sz="1200" b="1" spc="300" kern="0" dirty="0">
+            <a:pPr marL="0" indent="0">
+              <a:buNone/>
+            </a:pPr>
+            <a:r>
+              <a:rPr lang="en-US" sz="1200" b="1" kern="0" spc="300" dirty="0">
                 <a:solidFill>
                   <a:srgbClr val="69A297"/>
                 </a:solidFill>
@@ -11952,7 +12312,7 @@
           <a:bodyPr wrap="square" lIns="0" tIns="0" rIns="0" bIns="0" rtlCol="0" anchor="ctr"/>
           <a:lstStyle/>
           <a:p>
-            <a:pPr indent="0" marL="0">
+            <a:pPr marL="0" indent="0">
               <a:lnSpc>
                 <a:spcPct val="98000"/>
               </a:lnSpc>
@@ -11994,13 +12354,20 @@
           </a:solidFill>
           <a:ln/>
           <a:effectLst>
-            <a:outerShdw sx="100000" sy="100000" kx="0" ky="0" algn="bl" rotWithShape="0" blurRad="101600" dist="38100" dir="5400000">
+            <a:outerShdw blurRad="101600" dist="38100" dir="5400000" algn="bl" rotWithShape="0">
               <a:srgbClr val="9AA8A5">
                 <a:alpha val="28000"/>
               </a:srgbClr>
             </a:outerShdw>
           </a:effectLst>
         </p:spPr>
+        <p:txBody>
+          <a:bodyPr/>
+          <a:lstStyle/>
+          <a:p>
+            <a:endParaRPr lang="es-ES"/>
+          </a:p>
+        </p:txBody>
       </p:sp>
       <p:sp>
         <p:nvSpPr>
@@ -12021,6 +12388,13 @@
           </a:solidFill>
           <a:ln/>
         </p:spPr>
+        <p:txBody>
+          <a:bodyPr/>
+          <a:lstStyle/>
+          <a:p>
+            <a:endParaRPr lang="es-ES"/>
+          </a:p>
+        </p:txBody>
       </p:sp>
       <p:sp>
         <p:nvSpPr>
@@ -12043,7 +12417,7 @@
           <a:bodyPr wrap="square" lIns="0" tIns="0" rIns="0" bIns="0" rtlCol="0" anchor="ctr"/>
           <a:lstStyle/>
           <a:p>
-            <a:pPr indent="0" marL="0">
+            <a:pPr marL="0" indent="0">
               <a:buNone/>
             </a:pPr>
             <a:r>
@@ -12082,7 +12456,7 @@
           <a:bodyPr wrap="square" lIns="0" tIns="0" rIns="0" bIns="0" rtlCol="0" anchor="ctr"/>
           <a:lstStyle/>
           <a:p>
-            <a:pPr indent="0" marL="0">
+            <a:pPr marL="0" indent="0">
               <a:lnSpc>
                 <a:spcPct val="105000"/>
               </a:lnSpc>
@@ -12102,7 +12476,7 @@
             <a:endParaRPr lang="en-US" sz="1250" dirty="0"/>
           </a:p>
           <a:p>
-            <a:pPr indent="0" marL="0">
+            <a:pPr marL="0" indent="0">
               <a:lnSpc>
                 <a:spcPct val="105000"/>
               </a:lnSpc>
@@ -12122,7 +12496,7 @@
             <a:endParaRPr lang="en-US" sz="1250" dirty="0"/>
           </a:p>
           <a:p>
-            <a:pPr indent="0" marL="0">
+            <a:pPr marL="0" indent="0">
               <a:lnSpc>
                 <a:spcPct val="105000"/>
               </a:lnSpc>
@@ -12164,13 +12538,20 @@
           </a:solidFill>
           <a:ln/>
           <a:effectLst>
-            <a:outerShdw sx="100000" sy="100000" kx="0" ky="0" algn="bl" rotWithShape="0" blurRad="101600" dist="38100" dir="5400000">
+            <a:outerShdw blurRad="101600" dist="38100" dir="5400000" algn="bl" rotWithShape="0">
               <a:srgbClr val="9AA8A5">
                 <a:alpha val="28000"/>
               </a:srgbClr>
             </a:outerShdw>
           </a:effectLst>
         </p:spPr>
+        <p:txBody>
+          <a:bodyPr/>
+          <a:lstStyle/>
+          <a:p>
+            <a:endParaRPr lang="es-ES"/>
+          </a:p>
+        </p:txBody>
       </p:sp>
       <p:sp>
         <p:nvSpPr>
@@ -12191,6 +12572,13 @@
           </a:solidFill>
           <a:ln/>
         </p:spPr>
+        <p:txBody>
+          <a:bodyPr/>
+          <a:lstStyle/>
+          <a:p>
+            <a:endParaRPr lang="es-ES"/>
+          </a:p>
+        </p:txBody>
       </p:sp>
       <p:sp>
         <p:nvSpPr>
@@ -12213,7 +12601,7 @@
           <a:bodyPr wrap="square" lIns="0" tIns="0" rIns="0" bIns="0" rtlCol="0" anchor="ctr"/>
           <a:lstStyle/>
           <a:p>
-            <a:pPr indent="0" marL="0">
+            <a:pPr marL="0" indent="0">
               <a:buNone/>
             </a:pPr>
             <a:r>
@@ -12252,7 +12640,7 @@
           <a:bodyPr wrap="square" lIns="0" tIns="0" rIns="0" bIns="0" rtlCol="0" anchor="ctr"/>
           <a:lstStyle/>
           <a:p>
-            <a:pPr indent="0" marL="0">
+            <a:pPr marL="0" indent="0">
               <a:lnSpc>
                 <a:spcPct val="105000"/>
               </a:lnSpc>
@@ -12294,13 +12682,20 @@
           </a:solidFill>
           <a:ln/>
           <a:effectLst>
-            <a:outerShdw sx="100000" sy="100000" kx="0" ky="0" algn="bl" rotWithShape="0" blurRad="101600" dist="38100" dir="5400000">
+            <a:outerShdw blurRad="101600" dist="38100" dir="5400000" algn="bl" rotWithShape="0">
               <a:srgbClr val="9AA8A5">
                 <a:alpha val="28000"/>
               </a:srgbClr>
             </a:outerShdw>
           </a:effectLst>
         </p:spPr>
+        <p:txBody>
+          <a:bodyPr/>
+          <a:lstStyle/>
+          <a:p>
+            <a:endParaRPr lang="es-ES"/>
+          </a:p>
+        </p:txBody>
       </p:sp>
       <p:sp>
         <p:nvSpPr>
@@ -12321,6 +12716,13 @@
           </a:solidFill>
           <a:ln/>
         </p:spPr>
+        <p:txBody>
+          <a:bodyPr/>
+          <a:lstStyle/>
+          <a:p>
+            <a:endParaRPr lang="es-ES"/>
+          </a:p>
+        </p:txBody>
       </p:sp>
       <p:sp>
         <p:nvSpPr>
@@ -12343,7 +12745,7 @@
           <a:bodyPr wrap="square" lIns="0" tIns="0" rIns="0" bIns="0" rtlCol="0" anchor="ctr"/>
           <a:lstStyle/>
           <a:p>
-            <a:pPr indent="0" marL="0">
+            <a:pPr marL="0" indent="0">
               <a:buNone/>
             </a:pPr>
             <a:r>
@@ -12382,7 +12784,7 @@
           <a:bodyPr wrap="square" lIns="0" tIns="0" rIns="0" bIns="0" rtlCol="0" anchor="ctr"/>
           <a:lstStyle/>
           <a:p>
-            <a:pPr indent="0" marL="0">
+            <a:pPr marL="0" indent="0">
               <a:lnSpc>
                 <a:spcPct val="105000"/>
               </a:lnSpc>
@@ -12424,13 +12826,20 @@
           </a:solidFill>
           <a:ln/>
           <a:effectLst>
-            <a:outerShdw sx="100000" sy="100000" kx="0" ky="0" algn="bl" rotWithShape="0" blurRad="101600" dist="38100" dir="5400000">
+            <a:outerShdw blurRad="101600" dist="38100" dir="5400000" algn="bl" rotWithShape="0">
               <a:srgbClr val="9AA8A5">
                 <a:alpha val="28000"/>
               </a:srgbClr>
             </a:outerShdw>
           </a:effectLst>
         </p:spPr>
+        <p:txBody>
+          <a:bodyPr/>
+          <a:lstStyle/>
+          <a:p>
+            <a:endParaRPr lang="es-ES"/>
+          </a:p>
+        </p:txBody>
       </p:sp>
       <p:sp>
         <p:nvSpPr>
@@ -12451,6 +12860,13 @@
           </a:solidFill>
           <a:ln/>
         </p:spPr>
+        <p:txBody>
+          <a:bodyPr/>
+          <a:lstStyle/>
+          <a:p>
+            <a:endParaRPr lang="es-ES"/>
+          </a:p>
+        </p:txBody>
       </p:sp>
       <p:sp>
         <p:nvSpPr>
@@ -12473,7 +12889,7 @@
           <a:bodyPr wrap="square" lIns="0" tIns="0" rIns="0" bIns="0" rtlCol="0" anchor="ctr"/>
           <a:lstStyle/>
           <a:p>
-            <a:pPr indent="0" marL="0">
+            <a:pPr marL="0" indent="0">
               <a:buNone/>
             </a:pPr>
             <a:r>
@@ -12512,7 +12928,7 @@
           <a:bodyPr wrap="square" lIns="0" tIns="0" rIns="0" bIns="0" rtlCol="0" anchor="ctr"/>
           <a:lstStyle/>
           <a:p>
-            <a:pPr indent="0" marL="0">
+            <a:pPr marL="0" indent="0">
               <a:lnSpc>
                 <a:spcPct val="105000"/>
               </a:lnSpc>
@@ -12554,7 +12970,7 @@
           <a:bodyPr wrap="square" lIns="0" tIns="0" rIns="0" bIns="0" rtlCol="0" anchor="ctr"/>
           <a:lstStyle/>
           <a:p>
-            <a:pPr indent="0" marL="0">
+            <a:pPr marL="0" indent="0">
               <a:buNone/>
             </a:pPr>
             <a:r>
@@ -12593,7 +13009,7 @@
           <a:bodyPr wrap="square" rtlCol="0" anchor="ctr"/>
           <a:lstStyle/>
           <a:p>
-            <a:pPr algn="r" indent="0" marL="0">
+            <a:pPr marL="0" indent="0" algn="r">
               <a:buNone/>
             </a:pPr>
             <a:r>
@@ -12627,6 +13043,7 @@
         <a:solidFill>
           <a:srgbClr val="F5F5F2"/>
         </a:solidFill>
+        <a:effectLst/>
       </p:bgPr>
     </p:bg>
     <p:spTree>
@@ -12664,11 +13081,11 @@
           <a:bodyPr wrap="square" lIns="0" tIns="0" rIns="0" bIns="0" rtlCol="0" anchor="ctr"/>
           <a:lstStyle/>
           <a:p>
-            <a:pPr indent="0" marL="0">
-              <a:buNone/>
-            </a:pPr>
-            <a:r>
-              <a:rPr lang="en-US" sz="1200" b="1" spc="300" kern="0" dirty="0">
+            <a:pPr marL="0" indent="0">
+              <a:buNone/>
+            </a:pPr>
+            <a:r>
+              <a:rPr lang="en-US" sz="1200" b="1" kern="0" spc="300" dirty="0">
                 <a:solidFill>
                   <a:srgbClr val="69A297"/>
                 </a:solidFill>
@@ -12703,7 +13120,7 @@
           <a:bodyPr wrap="square" lIns="0" tIns="0" rIns="0" bIns="0" rtlCol="0" anchor="ctr"/>
           <a:lstStyle/>
           <a:p>
-            <a:pPr indent="0" marL="0">
+            <a:pPr marL="0" indent="0">
               <a:lnSpc>
                 <a:spcPct val="98000"/>
               </a:lnSpc>
@@ -12745,7 +13162,7 @@
           <a:bodyPr wrap="square" lIns="0" tIns="0" rIns="0" bIns="0" rtlCol="0" anchor="ctr"/>
           <a:lstStyle/>
           <a:p>
-            <a:pPr indent="0" marL="0">
+            <a:pPr marL="0" indent="0">
               <a:buNone/>
             </a:pPr>
             <a:r>
@@ -12784,13 +13201,20 @@
           </a:solidFill>
           <a:ln/>
           <a:effectLst>
-            <a:outerShdw sx="100000" sy="100000" kx="0" ky="0" algn="bl" rotWithShape="0" blurRad="101600" dist="38100" dir="5400000">
+            <a:outerShdw blurRad="101600" dist="38100" dir="5400000" algn="bl" rotWithShape="0">
               <a:srgbClr val="9AA8A5">
                 <a:alpha val="28000"/>
               </a:srgbClr>
             </a:outerShdw>
           </a:effectLst>
         </p:spPr>
+        <p:txBody>
+          <a:bodyPr/>
+          <a:lstStyle/>
+          <a:p>
+            <a:endParaRPr lang="es-ES"/>
+          </a:p>
+        </p:txBody>
       </p:sp>
       <p:sp>
         <p:nvSpPr>
@@ -12813,7 +13237,7 @@
           <a:bodyPr wrap="square" lIns="0" tIns="0" rIns="0" bIns="0" rtlCol="0" anchor="ctr"/>
           <a:lstStyle/>
           <a:p>
-            <a:pPr algn="ctr" indent="0" marL="0">
+            <a:pPr marL="0" indent="0" algn="ctr">
               <a:buNone/>
             </a:pPr>
             <a:r>
@@ -12852,7 +13276,7 @@
           <a:bodyPr wrap="square" lIns="0" tIns="0" rIns="0" bIns="0" rtlCol="0" anchor="ctr"/>
           <a:lstStyle/>
           <a:p>
-            <a:pPr algn="ctr" indent="0" marL="0">
+            <a:pPr marL="0" indent="0" algn="ctr">
               <a:buNone/>
             </a:pPr>
             <a:r>
@@ -12891,13 +13315,20 @@
           </a:solidFill>
           <a:ln/>
           <a:effectLst>
-            <a:outerShdw sx="100000" sy="100000" kx="0" ky="0" algn="bl" rotWithShape="0" blurRad="101600" dist="38100" dir="5400000">
+            <a:outerShdw blurRad="101600" dist="38100" dir="5400000" algn="bl" rotWithShape="0">
               <a:srgbClr val="9AA8A5">
                 <a:alpha val="28000"/>
               </a:srgbClr>
             </a:outerShdw>
           </a:effectLst>
         </p:spPr>
+        <p:txBody>
+          <a:bodyPr/>
+          <a:lstStyle/>
+          <a:p>
+            <a:endParaRPr lang="es-ES"/>
+          </a:p>
+        </p:txBody>
       </p:sp>
       <p:sp>
         <p:nvSpPr>
@@ -12920,7 +13351,7 @@
           <a:bodyPr wrap="square" lIns="0" tIns="0" rIns="0" bIns="0" rtlCol="0" anchor="ctr"/>
           <a:lstStyle/>
           <a:p>
-            <a:pPr algn="ctr" indent="0" marL="0">
+            <a:pPr marL="0" indent="0" algn="ctr">
               <a:buNone/>
             </a:pPr>
             <a:r>
@@ -12959,7 +13390,7 @@
           <a:bodyPr wrap="square" lIns="0" tIns="0" rIns="0" bIns="0" rtlCol="0" anchor="ctr"/>
           <a:lstStyle/>
           <a:p>
-            <a:pPr algn="ctr" indent="0" marL="0">
+            <a:pPr marL="0" indent="0" algn="ctr">
               <a:buNone/>
             </a:pPr>
             <a:r>
@@ -12998,13 +13429,20 @@
           </a:solidFill>
           <a:ln/>
           <a:effectLst>
-            <a:outerShdw sx="100000" sy="100000" kx="0" ky="0" algn="bl" rotWithShape="0" blurRad="101600" dist="38100" dir="5400000">
+            <a:outerShdw blurRad="101600" dist="38100" dir="5400000" algn="bl" rotWithShape="0">
               <a:srgbClr val="9AA8A5">
                 <a:alpha val="28000"/>
               </a:srgbClr>
             </a:outerShdw>
           </a:effectLst>
         </p:spPr>
+        <p:txBody>
+          <a:bodyPr/>
+          <a:lstStyle/>
+          <a:p>
+            <a:endParaRPr lang="es-ES"/>
+          </a:p>
+        </p:txBody>
       </p:sp>
       <p:sp>
         <p:nvSpPr>
@@ -13027,7 +13465,7 @@
           <a:bodyPr wrap="square" lIns="0" tIns="0" rIns="0" bIns="0" rtlCol="0" anchor="ctr"/>
           <a:lstStyle/>
           <a:p>
-            <a:pPr algn="ctr" indent="0" marL="0">
+            <a:pPr marL="0" indent="0" algn="ctr">
               <a:buNone/>
             </a:pPr>
             <a:r>
@@ -13066,7 +13504,7 @@
           <a:bodyPr wrap="square" lIns="0" tIns="0" rIns="0" bIns="0" rtlCol="0" anchor="ctr"/>
           <a:lstStyle/>
           <a:p>
-            <a:pPr algn="ctr" indent="0" marL="0">
+            <a:pPr marL="0" indent="0" algn="ctr">
               <a:buNone/>
             </a:pPr>
             <a:r>
@@ -13105,13 +13543,20 @@
           </a:solidFill>
           <a:ln/>
           <a:effectLst>
-            <a:outerShdw sx="100000" sy="100000" kx="0" ky="0" algn="bl" rotWithShape="0" blurRad="101600" dist="38100" dir="5400000">
+            <a:outerShdw blurRad="101600" dist="38100" dir="5400000" algn="bl" rotWithShape="0">
               <a:srgbClr val="9AA8A5">
                 <a:alpha val="28000"/>
               </a:srgbClr>
             </a:outerShdw>
           </a:effectLst>
         </p:spPr>
+        <p:txBody>
+          <a:bodyPr/>
+          <a:lstStyle/>
+          <a:p>
+            <a:endParaRPr lang="es-ES"/>
+          </a:p>
+        </p:txBody>
       </p:sp>
       <p:sp>
         <p:nvSpPr>
@@ -13134,7 +13579,7 @@
           <a:bodyPr wrap="square" lIns="0" tIns="0" rIns="0" bIns="0" rtlCol="0" anchor="ctr"/>
           <a:lstStyle/>
           <a:p>
-            <a:pPr algn="ctr" indent="0" marL="0">
+            <a:pPr marL="0" indent="0" algn="ctr">
               <a:buNone/>
             </a:pPr>
             <a:r>
@@ -13173,7 +13618,7 @@
           <a:bodyPr wrap="square" lIns="0" tIns="0" rIns="0" bIns="0" rtlCol="0" anchor="ctr"/>
           <a:lstStyle/>
           <a:p>
-            <a:pPr algn="ctr" indent="0" marL="0">
+            <a:pPr marL="0" indent="0" algn="ctr">
               <a:buNone/>
             </a:pPr>
             <a:r>
@@ -13212,7 +13657,7 @@
           <a:bodyPr wrap="square" lIns="0" tIns="0" rIns="0" bIns="0" rtlCol="0" anchor="ctr"/>
           <a:lstStyle/>
           <a:p>
-            <a:pPr indent="0" marL="0">
+            <a:pPr marL="0" indent="0">
               <a:buNone/>
             </a:pPr>
             <a:r>
@@ -13251,6 +13696,13 @@
           </a:solidFill>
           <a:ln/>
         </p:spPr>
+        <p:txBody>
+          <a:bodyPr/>
+          <a:lstStyle/>
+          <a:p>
+            <a:endParaRPr lang="es-ES"/>
+          </a:p>
+        </p:txBody>
       </p:sp>
       <p:sp>
         <p:nvSpPr>
@@ -13273,7 +13725,7 @@
           <a:bodyPr wrap="square" lIns="0" tIns="0" rIns="0" bIns="0" rtlCol="0" anchor="ctr"/>
           <a:lstStyle/>
           <a:p>
-            <a:pPr indent="0" marL="0">
+            <a:pPr marL="0" indent="0">
               <a:lnSpc>
                 <a:spcPct val="105000"/>
               </a:lnSpc>
@@ -13315,7 +13767,7 @@
           <a:bodyPr wrap="square" lIns="0" tIns="0" rIns="0" bIns="0" rtlCol="0" anchor="ctr"/>
           <a:lstStyle/>
           <a:p>
-            <a:pPr indent="0" marL="0">
+            <a:pPr marL="0" indent="0">
               <a:lnSpc>
                 <a:spcPct val="105000"/>
               </a:lnSpc>
@@ -13357,7 +13809,7 @@
           <a:bodyPr wrap="square" rtlCol="0" anchor="ctr"/>
           <a:lstStyle/>
           <a:p>
-            <a:pPr algn="r" indent="0" marL="0">
+            <a:pPr marL="0" indent="0" algn="r">
               <a:buNone/>
             </a:pPr>
             <a:r>
@@ -13391,6 +13843,7 @@
         <a:solidFill>
           <a:srgbClr val="F5F5F2"/>
         </a:solidFill>
+        <a:effectLst/>
       </p:bgPr>
     </p:bg>
     <p:spTree>
@@ -13428,11 +13881,11 @@
           <a:bodyPr wrap="square" lIns="0" tIns="0" rIns="0" bIns="0" rtlCol="0" anchor="ctr"/>
           <a:lstStyle/>
           <a:p>
-            <a:pPr indent="0" marL="0">
-              <a:buNone/>
-            </a:pPr>
-            <a:r>
-              <a:rPr lang="en-US" sz="1200" b="1" spc="300" kern="0" dirty="0">
+            <a:pPr marL="0" indent="0">
+              <a:buNone/>
+            </a:pPr>
+            <a:r>
+              <a:rPr lang="en-US" sz="1200" b="1" kern="0" spc="300" dirty="0">
                 <a:solidFill>
                   <a:srgbClr val="69A297"/>
                 </a:solidFill>
@@ -13467,7 +13920,7 @@
           <a:bodyPr wrap="square" lIns="0" tIns="0" rIns="0" bIns="0" rtlCol="0" anchor="ctr"/>
           <a:lstStyle/>
           <a:p>
-            <a:pPr indent="0" marL="0">
+            <a:pPr marL="0" indent="0">
               <a:lnSpc>
                 <a:spcPct val="98000"/>
               </a:lnSpc>
@@ -13509,6 +13962,13 @@
           </a:solidFill>
           <a:ln/>
         </p:spPr>
+        <p:txBody>
+          <a:bodyPr/>
+          <a:lstStyle/>
+          <a:p>
+            <a:endParaRPr lang="es-ES"/>
+          </a:p>
+        </p:txBody>
       </p:sp>
       <p:sp>
         <p:nvSpPr>
@@ -13531,7 +13991,7 @@
           <a:bodyPr wrap="square" lIns="0" tIns="0" rIns="0" bIns="0" rtlCol="0" anchor="ctr"/>
           <a:lstStyle/>
           <a:p>
-            <a:pPr algn="ctr" indent="0" marL="0">
+            <a:pPr marL="0" indent="0" algn="ctr">
               <a:buNone/>
             </a:pPr>
             <a:r>
@@ -13570,6 +14030,13 @@
           </a:solidFill>
           <a:ln/>
         </p:spPr>
+        <p:txBody>
+          <a:bodyPr/>
+          <a:lstStyle/>
+          <a:p>
+            <a:endParaRPr lang="es-ES"/>
+          </a:p>
+        </p:txBody>
       </p:sp>
       <p:sp>
         <p:nvSpPr>
@@ -13592,7 +14059,7 @@
           <a:bodyPr wrap="square" lIns="0" tIns="0" rIns="0" bIns="0" rtlCol="0" anchor="ctr"/>
           <a:lstStyle/>
           <a:p>
-            <a:pPr algn="ctr" indent="0" marL="0">
+            <a:pPr marL="0" indent="0" algn="ctr">
               <a:buNone/>
             </a:pPr>
             <a:r>
@@ -13631,6 +14098,13 @@
           </a:solidFill>
           <a:ln/>
         </p:spPr>
+        <p:txBody>
+          <a:bodyPr/>
+          <a:lstStyle/>
+          <a:p>
+            <a:endParaRPr lang="es-ES"/>
+          </a:p>
+        </p:txBody>
       </p:sp>
       <p:sp>
         <p:nvSpPr>
@@ -13653,7 +14127,7 @@
           <a:bodyPr wrap="square" lIns="0" tIns="0" rIns="0" bIns="0" rtlCol="0" anchor="ctr"/>
           <a:lstStyle/>
           <a:p>
-            <a:pPr algn="ctr" indent="0" marL="0">
+            <a:pPr marL="0" indent="0" algn="ctr">
               <a:buNone/>
             </a:pPr>
             <a:r>
@@ -13692,6 +14166,13 @@
           </a:solidFill>
           <a:ln/>
         </p:spPr>
+        <p:txBody>
+          <a:bodyPr/>
+          <a:lstStyle/>
+          <a:p>
+            <a:endParaRPr lang="es-ES"/>
+          </a:p>
+        </p:txBody>
       </p:sp>
       <p:sp>
         <p:nvSpPr>
@@ -13714,7 +14195,7 @@
           <a:bodyPr wrap="square" lIns="0" tIns="0" rIns="0" bIns="0" rtlCol="0" anchor="ctr"/>
           <a:lstStyle/>
           <a:p>
-            <a:pPr algn="ctr" indent="0" marL="0">
+            <a:pPr marL="0" indent="0" algn="ctr">
               <a:buNone/>
             </a:pPr>
             <a:r>
@@ -13753,6 +14234,13 @@
           </a:solidFill>
           <a:ln/>
         </p:spPr>
+        <p:txBody>
+          <a:bodyPr/>
+          <a:lstStyle/>
+          <a:p>
+            <a:endParaRPr lang="es-ES"/>
+          </a:p>
+        </p:txBody>
       </p:sp>
       <p:sp>
         <p:nvSpPr>
@@ -13775,7 +14263,7 @@
           <a:bodyPr wrap="square" lIns="0" tIns="0" rIns="0" bIns="0" rtlCol="0" anchor="ctr"/>
           <a:lstStyle/>
           <a:p>
-            <a:pPr algn="ctr" indent="0" marL="0">
+            <a:pPr marL="0" indent="0" algn="ctr">
               <a:buNone/>
             </a:pPr>
             <a:r>
@@ -13814,6 +14302,13 @@
           </a:solidFill>
           <a:ln/>
         </p:spPr>
+        <p:txBody>
+          <a:bodyPr/>
+          <a:lstStyle/>
+          <a:p>
+            <a:endParaRPr lang="es-ES"/>
+          </a:p>
+        </p:txBody>
       </p:sp>
       <p:sp>
         <p:nvSpPr>
@@ -13836,7 +14331,7 @@
           <a:bodyPr wrap="square" lIns="0" tIns="0" rIns="0" bIns="0" rtlCol="0" anchor="ctr"/>
           <a:lstStyle/>
           <a:p>
-            <a:pPr algn="ctr" indent="0" marL="0">
+            <a:pPr marL="0" indent="0" algn="ctr">
               <a:buNone/>
             </a:pPr>
             <a:r>
@@ -13875,6 +14370,13 @@
           </a:solidFill>
           <a:ln/>
         </p:spPr>
+        <p:txBody>
+          <a:bodyPr/>
+          <a:lstStyle/>
+          <a:p>
+            <a:endParaRPr lang="es-ES"/>
+          </a:p>
+        </p:txBody>
       </p:sp>
       <p:sp>
         <p:nvSpPr>
@@ -13897,7 +14399,7 @@
           <a:bodyPr wrap="square" lIns="0" tIns="0" rIns="0" bIns="0" rtlCol="0" anchor="ctr"/>
           <a:lstStyle/>
           <a:p>
-            <a:pPr algn="ctr" indent="0" marL="0">
+            <a:pPr marL="0" indent="0" algn="ctr">
               <a:buNone/>
             </a:pPr>
             <a:r>
@@ -14042,7 +14544,7 @@
           <a:bodyPr wrap="square" rtlCol="0" anchor="ctr"/>
           <a:lstStyle/>
           <a:p>
-            <a:pPr algn="r" indent="0" marL="0">
+            <a:pPr marL="0" indent="0" algn="r">
               <a:buNone/>
             </a:pPr>
             <a:r>
@@ -14361,4 +14863,319 @@
     </a:ext>
   </a:extLst>
 </a:theme>
+</file>
+
+<file path=ppt/theme/theme2.xml><?xml version="1.0" encoding="utf-8"?>
+<a:theme xmlns:a="http://schemas.openxmlformats.org/drawingml/2006/main" name="Tema de Office">
+  <a:themeElements>
+    <a:clrScheme name="Office">
+      <a:dk1>
+        <a:sysClr val="windowText" lastClr="000000"/>
+      </a:dk1>
+      <a:lt1>
+        <a:sysClr val="window" lastClr="FFFFFF"/>
+      </a:lt1>
+      <a:dk2>
+        <a:srgbClr val="0E2841"/>
+      </a:dk2>
+      <a:lt2>
+        <a:srgbClr val="E8E8E8"/>
+      </a:lt2>
+      <a:accent1>
+        <a:srgbClr val="156082"/>
+      </a:accent1>
+      <a:accent2>
+        <a:srgbClr val="E97132"/>
+      </a:accent2>
+      <a:accent3>
+        <a:srgbClr val="196B24"/>
+      </a:accent3>
+      <a:accent4>
+        <a:srgbClr val="0F9ED5"/>
+      </a:accent4>
+      <a:accent5>
+        <a:srgbClr val="A02B93"/>
+      </a:accent5>
+      <a:accent6>
+        <a:srgbClr val="4EA72E"/>
+      </a:accent6>
+      <a:hlink>
+        <a:srgbClr val="467886"/>
+      </a:hlink>
+      <a:folHlink>
+        <a:srgbClr val="96607D"/>
+      </a:folHlink>
+    </a:clrScheme>
+    <a:fontScheme name="Office">
+      <a:majorFont>
+        <a:latin typeface="Aptos Display" panose="02110004020202020204"/>
+        <a:ea typeface=""/>
+        <a:cs typeface=""/>
+        <a:font script="Jpan" typeface="游ゴシック Light"/>
+        <a:font script="Hang" typeface="맑은 고딕"/>
+        <a:font script="Hans" typeface="等线 Light"/>
+        <a:font script="Hant" typeface="新細明體"/>
+        <a:font script="Arab" typeface="Times New Roman"/>
+        <a:font script="Hebr" typeface="Times New Roman"/>
+        <a:font script="Thai" typeface="Angsana New"/>
+        <a:font script="Ethi" typeface="Nyala"/>
+        <a:font script="Beng" typeface="Vrinda"/>
+        <a:font script="Gujr" typeface="Shruti"/>
+        <a:font script="Khmr" typeface="MoolBoran"/>
+        <a:font script="Knda" typeface="Tunga"/>
+        <a:font script="Guru" typeface="Raavi"/>
+        <a:font script="Cans" typeface="Euphemia"/>
+        <a:font script="Cher" typeface="Plantagenet Cherokee"/>
+        <a:font script="Yiii" typeface="Microsoft Yi Baiti"/>
+        <a:font script="Tibt" typeface="Microsoft Himalaya"/>
+        <a:font script="Thaa" typeface="MV Boli"/>
+        <a:font script="Deva" typeface="Mangal"/>
+        <a:font script="Telu" typeface="Gautami"/>
+        <a:font script="Taml" typeface="Latha"/>
+        <a:font script="Syrc" typeface="Estrangelo Edessa"/>
+        <a:font script="Orya" typeface="Kalinga"/>
+        <a:font script="Mlym" typeface="Kartika"/>
+        <a:font script="Laoo" typeface="DokChampa"/>
+        <a:font script="Sinh" typeface="Iskoola Pota"/>
+        <a:font script="Mong" typeface="Mongolian Baiti"/>
+        <a:font script="Viet" typeface="Times New Roman"/>
+        <a:font script="Uigh" typeface="Microsoft Uighur"/>
+        <a:font script="Geor" typeface="Sylfaen"/>
+        <a:font script="Armn" typeface="Arial"/>
+        <a:font script="Bugi" typeface="Leelawadee UI"/>
+        <a:font script="Bopo" typeface="Microsoft JhengHei"/>
+        <a:font script="Java" typeface="Javanese Text"/>
+        <a:font script="Lisu" typeface="Segoe UI"/>
+        <a:font script="Mymr" typeface="Myanmar Text"/>
+        <a:font script="Nkoo" typeface="Ebrima"/>
+        <a:font script="Olck" typeface="Nirmala UI"/>
+        <a:font script="Osma" typeface="Ebrima"/>
+        <a:font script="Phag" typeface="Phagspa"/>
+        <a:font script="Syrn" typeface="Estrangelo Edessa"/>
+        <a:font script="Syrj" typeface="Estrangelo Edessa"/>
+        <a:font script="Syre" typeface="Estrangelo Edessa"/>
+        <a:font script="Sora" typeface="Nirmala UI"/>
+        <a:font script="Tale" typeface="Microsoft Tai Le"/>
+        <a:font script="Talu" typeface="Microsoft New Tai Lue"/>
+        <a:font script="Tfng" typeface="Ebrima"/>
+      </a:majorFont>
+      <a:minorFont>
+        <a:latin typeface="Aptos" panose="02110004020202020204"/>
+        <a:ea typeface=""/>
+        <a:cs typeface=""/>
+        <a:font script="Jpan" typeface="游ゴシック"/>
+        <a:font script="Hang" typeface="맑은 고딕"/>
+        <a:font script="Hans" typeface="等线"/>
+        <a:font script="Hant" typeface="新細明體"/>
+        <a:font script="Arab" typeface="Arial"/>
+        <a:font script="Hebr" typeface="Arial"/>
+        <a:font script="Thai" typeface="Cordia New"/>
+        <a:font script="Ethi" typeface="Nyala"/>
+        <a:font script="Beng" typeface="Vrinda"/>
+        <a:font script="Gujr" typeface="Shruti"/>
+        <a:font script="Khmr" typeface="DaunPenh"/>
+        <a:font script="Knda" typeface="Tunga"/>
+        <a:font script="Guru" typeface="Raavi"/>
+        <a:font script="Cans" typeface="Euphemia"/>
+        <a:font script="Cher" typeface="Plantagenet Cherokee"/>
+        <a:font script="Yiii" typeface="Microsoft Yi Baiti"/>
+        <a:font script="Tibt" typeface="Microsoft Himalaya"/>
+        <a:font script="Thaa" typeface="MV Boli"/>
+        <a:font script="Deva" typeface="Mangal"/>
+        <a:font script="Telu" typeface="Gautami"/>
+        <a:font script="Taml" typeface="Latha"/>
+        <a:font script="Syrc" typeface="Estrangelo Edessa"/>
+        <a:font script="Orya" typeface="Kalinga"/>
+        <a:font script="Mlym" typeface="Kartika"/>
+        <a:font script="Laoo" typeface="DokChampa"/>
+        <a:font script="Sinh" typeface="Iskoola Pota"/>
+        <a:font script="Mong" typeface="Mongolian Baiti"/>
+        <a:font script="Viet" typeface="Arial"/>
+        <a:font script="Uigh" typeface="Microsoft Uighur"/>
+        <a:font script="Geor" typeface="Sylfaen"/>
+        <a:font script="Armn" typeface="Arial"/>
+        <a:font script="Bugi" typeface="Leelawadee UI"/>
+        <a:font script="Bopo" typeface="Microsoft JhengHei"/>
+        <a:font script="Java" typeface="Javanese Text"/>
+        <a:font script="Lisu" typeface="Segoe UI"/>
+        <a:font script="Mymr" typeface="Myanmar Text"/>
+        <a:font script="Nkoo" typeface="Ebrima"/>
+        <a:font script="Olck" typeface="Nirmala UI"/>
+        <a:font script="Osma" typeface="Ebrima"/>
+        <a:font script="Phag" typeface="Phagspa"/>
+        <a:font script="Syrn" typeface="Estrangelo Edessa"/>
+        <a:font script="Syrj" typeface="Estrangelo Edessa"/>
+        <a:font script="Syre" typeface="Estrangelo Edessa"/>
+        <a:font script="Sora" typeface="Nirmala UI"/>
+        <a:font script="Tale" typeface="Microsoft Tai Le"/>
+        <a:font script="Talu" typeface="Microsoft New Tai Lue"/>
+        <a:font script="Tfng" typeface="Ebrima"/>
+      </a:minorFont>
+    </a:fontScheme>
+    <a:fmtScheme name="Office">
+      <a:fillStyleLst>
+        <a:solidFill>
+          <a:schemeClr val="phClr"/>
+        </a:solidFill>
+        <a:gradFill rotWithShape="1">
+          <a:gsLst>
+            <a:gs pos="0">
+              <a:schemeClr val="phClr">
+                <a:lumMod val="110000"/>
+                <a:satMod val="105000"/>
+                <a:tint val="67000"/>
+              </a:schemeClr>
+            </a:gs>
+            <a:gs pos="50000">
+              <a:schemeClr val="phClr">
+                <a:lumMod val="105000"/>
+                <a:satMod val="103000"/>
+                <a:tint val="73000"/>
+              </a:schemeClr>
+            </a:gs>
+            <a:gs pos="100000">
+              <a:schemeClr val="phClr">
+                <a:lumMod val="105000"/>
+                <a:satMod val="109000"/>
+                <a:tint val="81000"/>
+              </a:schemeClr>
+            </a:gs>
+          </a:gsLst>
+          <a:lin ang="5400000" scaled="0"/>
+        </a:gradFill>
+        <a:gradFill rotWithShape="1">
+          <a:gsLst>
+            <a:gs pos="0">
+              <a:schemeClr val="phClr">
+                <a:satMod val="103000"/>
+                <a:lumMod val="102000"/>
+                <a:tint val="94000"/>
+              </a:schemeClr>
+            </a:gs>
+            <a:gs pos="50000">
+              <a:schemeClr val="phClr">
+                <a:satMod val="110000"/>
+                <a:lumMod val="100000"/>
+                <a:shade val="100000"/>
+              </a:schemeClr>
+            </a:gs>
+            <a:gs pos="100000">
+              <a:schemeClr val="phClr">
+                <a:lumMod val="99000"/>
+                <a:satMod val="120000"/>
+                <a:shade val="78000"/>
+              </a:schemeClr>
+            </a:gs>
+          </a:gsLst>
+          <a:lin ang="5400000" scaled="0"/>
+        </a:gradFill>
+      </a:fillStyleLst>
+      <a:lnStyleLst>
+        <a:ln w="12700" cap="flat" cmpd="sng" algn="ctr">
+          <a:solidFill>
+            <a:schemeClr val="phClr"/>
+          </a:solidFill>
+          <a:prstDash val="solid"/>
+          <a:miter lim="800000"/>
+        </a:ln>
+        <a:ln w="19050" cap="flat" cmpd="sng" algn="ctr">
+          <a:solidFill>
+            <a:schemeClr val="phClr"/>
+          </a:solidFill>
+          <a:prstDash val="solid"/>
+          <a:miter lim="800000"/>
+        </a:ln>
+        <a:ln w="25400" cap="flat" cmpd="sng" algn="ctr">
+          <a:solidFill>
+            <a:schemeClr val="phClr"/>
+          </a:solidFill>
+          <a:prstDash val="solid"/>
+          <a:miter lim="800000"/>
+        </a:ln>
+      </a:lnStyleLst>
+      <a:effectStyleLst>
+        <a:effectStyle>
+          <a:effectLst/>
+        </a:effectStyle>
+        <a:effectStyle>
+          <a:effectLst/>
+        </a:effectStyle>
+        <a:effectStyle>
+          <a:effectLst>
+            <a:outerShdw blurRad="57150" dist="19050" dir="5400000" algn="ctr" rotWithShape="0">
+              <a:srgbClr val="000000">
+                <a:alpha val="63000"/>
+              </a:srgbClr>
+            </a:outerShdw>
+          </a:effectLst>
+        </a:effectStyle>
+      </a:effectStyleLst>
+      <a:bgFillStyleLst>
+        <a:solidFill>
+          <a:schemeClr val="phClr"/>
+        </a:solidFill>
+        <a:solidFill>
+          <a:schemeClr val="phClr">
+            <a:tint val="95000"/>
+            <a:satMod val="170000"/>
+          </a:schemeClr>
+        </a:solidFill>
+        <a:gradFill rotWithShape="1">
+          <a:gsLst>
+            <a:gs pos="0">
+              <a:schemeClr val="phClr">
+                <a:tint val="93000"/>
+                <a:satMod val="150000"/>
+                <a:shade val="98000"/>
+                <a:lumMod val="102000"/>
+              </a:schemeClr>
+            </a:gs>
+            <a:gs pos="50000">
+              <a:schemeClr val="phClr">
+                <a:tint val="98000"/>
+                <a:satMod val="130000"/>
+                <a:shade val="90000"/>
+                <a:lumMod val="103000"/>
+              </a:schemeClr>
+            </a:gs>
+            <a:gs pos="100000">
+              <a:schemeClr val="phClr">
+                <a:shade val="63000"/>
+                <a:satMod val="120000"/>
+              </a:schemeClr>
+            </a:gs>
+          </a:gsLst>
+          <a:lin ang="5400000" scaled="0"/>
+        </a:gradFill>
+      </a:bgFillStyleLst>
+    </a:fmtScheme>
+  </a:themeElements>
+  <a:objectDefaults>
+    <a:lnDef>
+      <a:spPr/>
+      <a:bodyPr/>
+      <a:lstStyle/>
+      <a:style>
+        <a:lnRef idx="2">
+          <a:schemeClr val="accent1"/>
+        </a:lnRef>
+        <a:fillRef idx="0">
+          <a:schemeClr val="accent1"/>
+        </a:fillRef>
+        <a:effectRef idx="1">
+          <a:schemeClr val="accent1"/>
+        </a:effectRef>
+        <a:fontRef idx="minor">
+          <a:schemeClr val="tx1"/>
+        </a:fontRef>
+      </a:style>
+    </a:lnDef>
+  </a:objectDefaults>
+  <a:extraClrSchemeLst/>
+  <a:extLst>
+    <a:ext uri="{05A4C25C-085E-4340-85A3-A5531E510DB2}">
+      <thm15:themeFamily xmlns:thm15="http://schemas.microsoft.com/office/thememl/2012/main" name="Office Theme" id="{2E142A2C-CD16-42D6-873A-C26D2A0506FA}" vid="{1BDDFF52-6CD6-40A5-AB3C-68EB2F1E4D0A}"/>
+    </a:ext>
+  </a:extLst>
+</a:theme>
 </file>
</xml_diff>